<commit_message>
Week 8 slide update
</commit_message>
<xml_diff>
--- a/Weekly Reports/slides/3-ethan-bishop.pptx
+++ b/Weekly Reports/slides/3-ethan-bishop.pptx
@@ -261,7 +261,7 @@
           <a:p>
             <a:fld id="{752E6B35-DAD5-CF47-9E65-9CA12B499D8C}" type="datetimeFigureOut">
               <a:rPr lang="en-US" smtClean="0"/>
-              <a:t>10/6/2026</a:t>
+              <a:t>10/13/2026</a:t>
             </a:fld>
             <a:endParaRPr lang="en-US"/>
           </a:p>
@@ -459,7 +459,7 @@
           <a:p>
             <a:fld id="{752E6B35-DAD5-CF47-9E65-9CA12B499D8C}" type="datetimeFigureOut">
               <a:rPr lang="en-US" smtClean="0"/>
-              <a:t>10/6/2026</a:t>
+              <a:t>10/13/2026</a:t>
             </a:fld>
             <a:endParaRPr lang="en-US"/>
           </a:p>
@@ -667,7 +667,7 @@
           <a:p>
             <a:fld id="{752E6B35-DAD5-CF47-9E65-9CA12B499D8C}" type="datetimeFigureOut">
               <a:rPr lang="en-US" smtClean="0"/>
-              <a:t>10/6/2026</a:t>
+              <a:t>10/13/2026</a:t>
             </a:fld>
             <a:endParaRPr lang="en-US"/>
           </a:p>
@@ -865,7 +865,7 @@
           <a:p>
             <a:fld id="{752E6B35-DAD5-CF47-9E65-9CA12B499D8C}" type="datetimeFigureOut">
               <a:rPr lang="en-US" smtClean="0"/>
-              <a:t>10/6/2026</a:t>
+              <a:t>10/13/2026</a:t>
             </a:fld>
             <a:endParaRPr lang="en-US"/>
           </a:p>
@@ -1140,7 +1140,7 @@
           <a:p>
             <a:fld id="{752E6B35-DAD5-CF47-9E65-9CA12B499D8C}" type="datetimeFigureOut">
               <a:rPr lang="en-US" smtClean="0"/>
-              <a:t>10/6/2026</a:t>
+              <a:t>10/13/2026</a:t>
             </a:fld>
             <a:endParaRPr lang="en-US"/>
           </a:p>
@@ -1405,7 +1405,7 @@
           <a:p>
             <a:fld id="{752E6B35-DAD5-CF47-9E65-9CA12B499D8C}" type="datetimeFigureOut">
               <a:rPr lang="en-US" smtClean="0"/>
-              <a:t>10/6/2026</a:t>
+              <a:t>10/13/2026</a:t>
             </a:fld>
             <a:endParaRPr lang="en-US"/>
           </a:p>
@@ -1817,7 +1817,7 @@
           <a:p>
             <a:fld id="{752E6B35-DAD5-CF47-9E65-9CA12B499D8C}" type="datetimeFigureOut">
               <a:rPr lang="en-US" smtClean="0"/>
-              <a:t>10/6/2026</a:t>
+              <a:t>10/13/2026</a:t>
             </a:fld>
             <a:endParaRPr lang="en-US"/>
           </a:p>
@@ -1958,7 +1958,7 @@
           <a:p>
             <a:fld id="{752E6B35-DAD5-CF47-9E65-9CA12B499D8C}" type="datetimeFigureOut">
               <a:rPr lang="en-US" smtClean="0"/>
-              <a:t>10/6/2026</a:t>
+              <a:t>10/13/2026</a:t>
             </a:fld>
             <a:endParaRPr lang="en-US"/>
           </a:p>
@@ -2071,7 +2071,7 @@
           <a:p>
             <a:fld id="{752E6B35-DAD5-CF47-9E65-9CA12B499D8C}" type="datetimeFigureOut">
               <a:rPr lang="en-US" smtClean="0"/>
-              <a:t>10/6/2026</a:t>
+              <a:t>10/13/2026</a:t>
             </a:fld>
             <a:endParaRPr lang="en-US"/>
           </a:p>
@@ -2382,7 +2382,7 @@
           <a:p>
             <a:fld id="{752E6B35-DAD5-CF47-9E65-9CA12B499D8C}" type="datetimeFigureOut">
               <a:rPr lang="en-US" smtClean="0"/>
-              <a:t>10/6/2026</a:t>
+              <a:t>10/13/2026</a:t>
             </a:fld>
             <a:endParaRPr lang="en-US"/>
           </a:p>
@@ -2670,7 +2670,7 @@
           <a:p>
             <a:fld id="{752E6B35-DAD5-CF47-9E65-9CA12B499D8C}" type="datetimeFigureOut">
               <a:rPr lang="en-US" smtClean="0"/>
-              <a:t>10/6/2026</a:t>
+              <a:t>10/13/2026</a:t>
             </a:fld>
             <a:endParaRPr lang="en-US"/>
           </a:p>
@@ -2911,7 +2911,7 @@
           <a:p>
             <a:fld id="{752E6B35-DAD5-CF47-9E65-9CA12B499D8C}" type="datetimeFigureOut">
               <a:rPr lang="en-US" smtClean="0"/>
-              <a:t>10/6/2026</a:t>
+              <a:t>10/13/2026</a:t>
             </a:fld>
             <a:endParaRPr lang="en-US"/>
           </a:p>
@@ -3386,7 +3386,7 @@
         </p:spPr>
         <p:txBody>
           <a:bodyPr>
-            <a:normAutofit lnSpcReduction="10000"/>
+            <a:normAutofit/>
           </a:bodyPr>
           <a:lstStyle/>
           <a:p>
@@ -3400,21 +3400,6 @@
             <a:pPr lvl="1"/>
             <a:r>
               <a:rPr lang="en-US" dirty="0"/>
-              <a:t>Research 3D printing </a:t>
-            </a:r>
-            <a:r>
-              <a:rPr lang="en-US" dirty="0" err="1"/>
-              <a:t>stl</a:t>
-            </a:r>
-            <a:r>
-              <a:rPr lang="en-US" dirty="0"/>
-              <a:t> files for the chassis</a:t>
-            </a:r>
-          </a:p>
-          <a:p>
-            <a:pPr lvl="1"/>
-            <a:r>
-              <a:rPr lang="en-US" dirty="0"/>
               <a:t>Research possible ROS implementation</a:t>
             </a:r>
           </a:p>
@@ -3422,21 +3407,6 @@
             <a:r>
               <a:rPr b="1" dirty="0"/>
               <a:t>Progress for the week</a:t>
-            </a:r>
-          </a:p>
-          <a:p>
-            <a:pPr lvl="1"/>
-            <a:r>
-              <a:rPr lang="en-US" dirty="0"/>
-              <a:t>Researched 3D printing </a:t>
-            </a:r>
-            <a:r>
-              <a:rPr lang="en-US" dirty="0" err="1"/>
-              <a:t>stl</a:t>
-            </a:r>
-            <a:r>
-              <a:rPr lang="en-US" dirty="0"/>
-              <a:t> files for the chassis</a:t>
             </a:r>
           </a:p>
           <a:p>
@@ -3892,7 +3862,7 @@
         </p:spPr>
         <p:txBody>
           <a:bodyPr>
-            <a:normAutofit fontScale="85000" lnSpcReduction="20000"/>
+            <a:normAutofit fontScale="70000" lnSpcReduction="20000"/>
           </a:bodyPr>
           <a:lstStyle/>
           <a:p>
@@ -3916,25 +3886,55 @@
           <a:p>
             <a:r>
               <a:rPr lang="en-US" sz="2200" dirty="0"/>
-              <a:t>Camera node: Streams live 640×480 video to the rest of the system</a:t>
+              <a:t>Camera node: Streams live video from the Pi Camera Module 3, with autofocus</a:t>
             </a:r>
           </a:p>
           <a:p>
             <a:r>
               <a:rPr lang="en-US" sz="2200" dirty="0"/>
-              <a:t>Sign detector node: Runs our recognition model and reports each sign's type, confidence and position</a:t>
+              <a:t>Sign detector node: Runs the vision model on each frame and reports every sign’s type, confidence and position</a:t>
             </a:r>
           </a:p>
           <a:p>
             <a:r>
               <a:rPr lang="en-US" sz="2200" dirty="0"/>
-              <a:t>Behavior node: A state machine that turns signs into driving decisions (stop, speed limit, turn)</a:t>
+              <a:t>IMU node: Reports the car’s turning and motion, and detects when it’s stuck</a:t>
             </a:r>
           </a:p>
           <a:p>
             <a:r>
               <a:rPr lang="en-US" sz="2200" dirty="0"/>
-              <a:t>Motor driver node: Converts speed and steering commands into motor signals on the HAT over I2C</a:t>
+              <a:t>Behavior node: A state machine that combines sign detections and IMU data into driving decisions (stop, slow down, turn)</a:t>
+            </a:r>
+          </a:p>
+          <a:p>
+            <a:r>
+              <a:rPr lang="en-US" sz="2200" dirty="0"/>
+              <a:t>Motor driver node: Turns speed and steering commands into wheel power through the </a:t>
+            </a:r>
+            <a:r>
+              <a:rPr lang="en-US" sz="2200" dirty="0" err="1"/>
+              <a:t>Waveshare</a:t>
+            </a:r>
+            <a:r>
+              <a:rPr lang="en-US" sz="2200" dirty="0"/>
+              <a:t> Motor Driver HAT, and stops the motors automatically if commands stop arriving</a:t>
+            </a:r>
+          </a:p>
+          <a:p>
+            <a:r>
+              <a:rPr lang="en-US" sz="2200" dirty="0"/>
+              <a:t>LCD node: Shows the car’s current state and the last sign it detected</a:t>
+            </a:r>
+          </a:p>
+          <a:p>
+            <a:r>
+              <a:rPr lang="en-US" sz="2200" dirty="0" err="1"/>
+              <a:t>Teleop</a:t>
+            </a:r>
+            <a:r>
+              <a:rPr lang="en-US" sz="2200" dirty="0"/>
+              <a:t> node: Lets a person take over and drive the car manually</a:t>
             </a:r>
           </a:p>
           <a:p>

</xml_diff>

<commit_message>
Week 9 slide update
</commit_message>
<xml_diff>
--- a/Weekly Reports/slides/3-ethan-bishop.pptx
+++ b/Weekly Reports/slides/3-ethan-bishop.pptx
@@ -7,7 +7,7 @@
   <p:sldIdLst>
     <p:sldId id="261" r:id="rId2"/>
     <p:sldId id="263" r:id="rId3"/>
-    <p:sldId id="262" r:id="rId4"/>
+    <p:sldId id="265" r:id="rId4"/>
   </p:sldIdLst>
   <p:sldSz cx="12192000" cy="6858000"/>
   <p:notesSz cx="6858000" cy="9144000"/>
@@ -261,7 +261,7 @@
           <a:p>
             <a:fld id="{752E6B35-DAD5-CF47-9E65-9CA12B499D8C}" type="datetimeFigureOut">
               <a:rPr lang="en-US" smtClean="0"/>
-              <a:t>10/13/2026</a:t>
+              <a:t>10/19/2026</a:t>
             </a:fld>
             <a:endParaRPr lang="en-US"/>
           </a:p>
@@ -459,7 +459,7 @@
           <a:p>
             <a:fld id="{752E6B35-DAD5-CF47-9E65-9CA12B499D8C}" type="datetimeFigureOut">
               <a:rPr lang="en-US" smtClean="0"/>
-              <a:t>10/13/2026</a:t>
+              <a:t>10/19/2026</a:t>
             </a:fld>
             <a:endParaRPr lang="en-US"/>
           </a:p>
@@ -667,7 +667,7 @@
           <a:p>
             <a:fld id="{752E6B35-DAD5-CF47-9E65-9CA12B499D8C}" type="datetimeFigureOut">
               <a:rPr lang="en-US" smtClean="0"/>
-              <a:t>10/13/2026</a:t>
+              <a:t>10/19/2026</a:t>
             </a:fld>
             <a:endParaRPr lang="en-US"/>
           </a:p>
@@ -865,7 +865,7 @@
           <a:p>
             <a:fld id="{752E6B35-DAD5-CF47-9E65-9CA12B499D8C}" type="datetimeFigureOut">
               <a:rPr lang="en-US" smtClean="0"/>
-              <a:t>10/13/2026</a:t>
+              <a:t>10/19/2026</a:t>
             </a:fld>
             <a:endParaRPr lang="en-US"/>
           </a:p>
@@ -1140,7 +1140,7 @@
           <a:p>
             <a:fld id="{752E6B35-DAD5-CF47-9E65-9CA12B499D8C}" type="datetimeFigureOut">
               <a:rPr lang="en-US" smtClean="0"/>
-              <a:t>10/13/2026</a:t>
+              <a:t>10/19/2026</a:t>
             </a:fld>
             <a:endParaRPr lang="en-US"/>
           </a:p>
@@ -1405,7 +1405,7 @@
           <a:p>
             <a:fld id="{752E6B35-DAD5-CF47-9E65-9CA12B499D8C}" type="datetimeFigureOut">
               <a:rPr lang="en-US" smtClean="0"/>
-              <a:t>10/13/2026</a:t>
+              <a:t>10/19/2026</a:t>
             </a:fld>
             <a:endParaRPr lang="en-US"/>
           </a:p>
@@ -1817,7 +1817,7 @@
           <a:p>
             <a:fld id="{752E6B35-DAD5-CF47-9E65-9CA12B499D8C}" type="datetimeFigureOut">
               <a:rPr lang="en-US" smtClean="0"/>
-              <a:t>10/13/2026</a:t>
+              <a:t>10/19/2026</a:t>
             </a:fld>
             <a:endParaRPr lang="en-US"/>
           </a:p>
@@ -1958,7 +1958,7 @@
           <a:p>
             <a:fld id="{752E6B35-DAD5-CF47-9E65-9CA12B499D8C}" type="datetimeFigureOut">
               <a:rPr lang="en-US" smtClean="0"/>
-              <a:t>10/13/2026</a:t>
+              <a:t>10/19/2026</a:t>
             </a:fld>
             <a:endParaRPr lang="en-US"/>
           </a:p>
@@ -2071,7 +2071,7 @@
           <a:p>
             <a:fld id="{752E6B35-DAD5-CF47-9E65-9CA12B499D8C}" type="datetimeFigureOut">
               <a:rPr lang="en-US" smtClean="0"/>
-              <a:t>10/13/2026</a:t>
+              <a:t>10/19/2026</a:t>
             </a:fld>
             <a:endParaRPr lang="en-US"/>
           </a:p>
@@ -2382,7 +2382,7 @@
           <a:p>
             <a:fld id="{752E6B35-DAD5-CF47-9E65-9CA12B499D8C}" type="datetimeFigureOut">
               <a:rPr lang="en-US" smtClean="0"/>
-              <a:t>10/13/2026</a:t>
+              <a:t>10/19/2026</a:t>
             </a:fld>
             <a:endParaRPr lang="en-US"/>
           </a:p>
@@ -2670,7 +2670,7 @@
           <a:p>
             <a:fld id="{752E6B35-DAD5-CF47-9E65-9CA12B499D8C}" type="datetimeFigureOut">
               <a:rPr lang="en-US" smtClean="0"/>
-              <a:t>10/13/2026</a:t>
+              <a:t>10/19/2026</a:t>
             </a:fld>
             <a:endParaRPr lang="en-US"/>
           </a:p>
@@ -2911,7 +2911,7 @@
           <a:p>
             <a:fld id="{752E6B35-DAD5-CF47-9E65-9CA12B499D8C}" type="datetimeFigureOut">
               <a:rPr lang="en-US" smtClean="0"/>
-              <a:t>10/13/2026</a:t>
+              <a:t>10/19/2026</a:t>
             </a:fld>
             <a:endParaRPr lang="en-US"/>
           </a:p>
@@ -3400,7 +3400,7 @@
             <a:pPr lvl="1"/>
             <a:r>
               <a:rPr lang="en-US" dirty="0"/>
-              <a:t>Research possible ROS implementation</a:t>
+              <a:t>Research on a possible ROS 2 implementation</a:t>
             </a:r>
           </a:p>
           <a:p>
@@ -3413,7 +3413,14 @@
             <a:pPr lvl="1"/>
             <a:r>
               <a:rPr lang="en-US" dirty="0"/>
-              <a:t>Continue research on a possible ROS 2 implementation</a:t>
+              <a:t>Installed ROS 2 under WSL</a:t>
+            </a:r>
+          </a:p>
+          <a:p>
+            <a:pPr lvl="1"/>
+            <a:r>
+              <a:rPr lang="en-US" dirty="0"/>
+              <a:t>Drafted the ROS 2 node architecture</a:t>
             </a:r>
           </a:p>
           <a:p>
@@ -3426,7 +3433,15 @@
             <a:pPr lvl="1"/>
             <a:r>
               <a:rPr lang="en-US" dirty="0"/>
-              <a:t>Continue research on a possible ROS 2 implementation</a:t>
+              <a:t>Create a test </a:t>
+            </a:r>
+            <a:r>
+              <a:rPr lang="en-US"/>
+              <a:t>program for </a:t>
+            </a:r>
+            <a:r>
+              <a:rPr lang="en-US" dirty="0"/>
+              <a:t>ROS 2 implementation</a:t>
             </a:r>
           </a:p>
           <a:p>
@@ -3464,14 +3479,6 @@
 <file path=ppt/slides/slide2.xml><?xml version="1.0" encoding="utf-8"?>
 <p:sld xmlns:a="http://schemas.openxmlformats.org/drawingml/2006/main" xmlns:r="http://schemas.openxmlformats.org/officeDocument/2006/relationships" xmlns:p="http://schemas.openxmlformats.org/presentationml/2006/main">
   <p:cSld>
-    <p:bg>
-      <p:bgPr>
-        <a:solidFill>
-          <a:schemeClr val="bg1"/>
-        </a:solidFill>
-        <a:effectLst/>
-      </p:bgPr>
-    </p:bg>
     <p:spTree>
       <p:nvGrpSpPr>
         <p:cNvPr id="1" name=""/>
@@ -3486,483 +3493,641 @@
           <a:chExt cx="0" cy="0"/>
         </a:xfrm>
       </p:grpSpPr>
-      <p:sp useBgFill="1">
-        <p:nvSpPr>
-          <p:cNvPr id="8" name="Rectangle 7">
-            <a:extLst>
-              <a:ext uri="{FF2B5EF4-FFF2-40B4-BE49-F238E27FC236}">
-                <a16:creationId xmlns:a16="http://schemas.microsoft.com/office/drawing/2014/main" id="{DAF1966E-FD40-4A4A-B61B-C4DF7FA05F06}"/>
-              </a:ext>
-              <a:ext uri="{C183D7F6-B498-43B3-948B-1728B52AA6E4}">
-                <adec:decorative xmlns:adec="http://schemas.microsoft.com/office/drawing/2017/decorative" val="1"/>
-              </a:ext>
-            </a:extLst>
-          </p:cNvPr>
-          <p:cNvSpPr>
-            <a:spLocks noGrp="1" noRot="1" noChangeAspect="1" noMove="1" noResize="1" noEditPoints="1" noAdjustHandles="1" noChangeArrowheads="1" noChangeShapeType="1" noTextEdit="1"/>
-          </p:cNvSpPr>
-          <p:nvPr>
-            <p:extLst>
-              <p:ext uri="{386F3935-93C4-4BCD-93E2-E3B085C9AB24}">
-                <p16:designElem xmlns:p16="http://schemas.microsoft.com/office/powerpoint/2015/main" val="1"/>
-              </p:ext>
-            </p:extLst>
+      <p:sp>
+        <p:nvSpPr>
+          <p:cNvPr id="2" name="Title"/>
+          <p:cNvSpPr>
+            <a:spLocks noGrp="1"/>
+          </p:cNvSpPr>
+          <p:nvPr>
+            <p:ph type="title"/>
           </p:nvPr>
         </p:nvSpPr>
         <p:spPr>
           <a:xfrm>
-            <a:off x="0" y="0"/>
-            <a:ext cx="12192000" cy="6858000"/>
+            <a:off x="768096" y="365760"/>
+            <a:ext cx="10789920" cy="658368"/>
+          </a:xfrm>
+        </p:spPr>
+        <p:txBody>
+          <a:bodyPr lIns="0" tIns="0" rIns="0" bIns="0" anchor="b">
+            <a:normAutofit/>
+          </a:bodyPr>
+          <a:lstStyle/>
+          <a:p>
+            <a:pPr algn="l"/>
+            <a:r>
+              <a:rPr lang="en-US" sz="3500" b="0" dirty="0">
+                <a:solidFill>
+                  <a:srgbClr val="000000"/>
+                </a:solidFill>
+                <a:latin typeface="Aptos Display"/>
+                <a:ea typeface="Aptos Display"/>
+                <a:cs typeface="Aptos Display"/>
+              </a:rPr>
+              <a:t>ROS 2 could split our pipeline into eight nodes</a:t>
+            </a:r>
+          </a:p>
+        </p:txBody>
+      </p:sp>
+      <p:sp>
+        <p:nvSpPr>
+          <p:cNvPr id="3" name="Subtitle"/>
+          <p:cNvSpPr txBox="1"/>
+          <p:nvPr/>
+        </p:nvSpPr>
+        <p:spPr>
+          <a:xfrm>
+            <a:off x="786384" y="1024128"/>
+            <a:ext cx="10607040" cy="365760"/>
           </a:xfrm>
           <a:prstGeom prst="rect">
             <a:avLst/>
           </a:prstGeom>
-          <a:ln>
-            <a:noFill/>
-          </a:ln>
-        </p:spPr>
-        <p:style>
-          <a:lnRef idx="2">
-            <a:schemeClr val="accent1">
-              <a:shade val="50000"/>
-            </a:schemeClr>
-          </a:lnRef>
-          <a:fillRef idx="1">
-            <a:schemeClr val="accent1"/>
-          </a:fillRef>
-          <a:effectRef idx="0">
-            <a:schemeClr val="accent1"/>
-          </a:effectRef>
-          <a:fontRef idx="minor">
-            <a:schemeClr val="lt1"/>
-          </a:fontRef>
-        </p:style>
-        <p:txBody>
-          <a:bodyPr rtlCol="0" anchor="ctr"/>
-          <a:lstStyle/>
-          <a:p>
-            <a:pPr algn="ctr"/>
-            <a:endParaRPr lang="en-US"/>
-          </a:p>
-        </p:txBody>
-      </p:sp>
-      <p:sp useBgFill="1">
-        <p:nvSpPr>
-          <p:cNvPr id="10" name="Rectangle 9">
-            <a:extLst>
-              <a:ext uri="{FF2B5EF4-FFF2-40B4-BE49-F238E27FC236}">
-                <a16:creationId xmlns:a16="http://schemas.microsoft.com/office/drawing/2014/main" id="{047BFA19-D45E-416B-A404-7AF2F3F27017}"/>
-              </a:ext>
-              <a:ext uri="{C183D7F6-B498-43B3-948B-1728B52AA6E4}">
-                <adec:decorative xmlns:adec="http://schemas.microsoft.com/office/drawing/2017/decorative" val="1"/>
-              </a:ext>
-            </a:extLst>
-          </p:cNvPr>
-          <p:cNvSpPr>
-            <a:spLocks noGrp="1" noRot="1" noChangeAspect="1" noMove="1" noResize="1" noEditPoints="1" noAdjustHandles="1" noChangeArrowheads="1" noChangeShapeType="1" noTextEdit="1"/>
-          </p:cNvSpPr>
-          <p:nvPr>
-            <p:extLst>
-              <p:ext uri="{386F3935-93C4-4BCD-93E2-E3B085C9AB24}">
-                <p16:designElem xmlns:p16="http://schemas.microsoft.com/office/powerpoint/2015/main" val="1"/>
-              </p:ext>
-            </p:extLst>
-          </p:nvPr>
+          <a:noFill/>
+        </p:spPr>
+        <p:txBody>
+          <a:bodyPr wrap="square" lIns="0" tIns="0" rIns="0" bIns="0" anchor="t">
+            <a:noAutofit/>
+          </a:bodyPr>
+          <a:lstStyle/>
+          <a:p>
+            <a:pPr marL="0" indent="0" algn="l">
+              <a:spcBef>
+                <a:spcPts val="0"/>
+              </a:spcBef>
+              <a:buNone/>
+            </a:pPr>
+            <a:r>
+              <a:rPr lang="en-US" sz="1500" b="1" dirty="0">
+                <a:solidFill>
+                  <a:srgbClr val="000000"/>
+                </a:solidFill>
+                <a:latin typeface="Aptos"/>
+                <a:ea typeface="Aptos"/>
+                <a:cs typeface="Aptos"/>
+              </a:rPr>
+              <a:t>Preliminary node structure for the car; each node does one job</a:t>
+            </a:r>
+          </a:p>
+        </p:txBody>
+      </p:sp>
+      <p:sp>
+        <p:nvSpPr>
+          <p:cNvPr id="4" name="Nodes"/>
+          <p:cNvSpPr txBox="1"/>
+          <p:nvPr/>
         </p:nvSpPr>
         <p:spPr>
           <a:xfrm>
-            <a:off x="558209" y="0"/>
-            <a:ext cx="11167447" cy="2018806"/>
+            <a:off x="786384" y="1719072"/>
+            <a:ext cx="6309360" cy="384048"/>
           </a:xfrm>
           <a:prstGeom prst="rect">
             <a:avLst/>
           </a:prstGeom>
-          <a:ln w="9525">
-            <a:solidFill>
-              <a:srgbClr val="E1E1E1"/>
-            </a:solidFill>
-          </a:ln>
-          <a:effectLst>
-            <a:outerShdw blurRad="50800" dist="38100" dir="2700000" algn="tl" rotWithShape="0">
-              <a:schemeClr val="bg1">
-                <a:lumMod val="85000"/>
-                <a:alpha val="50000"/>
-              </a:schemeClr>
-            </a:outerShdw>
-          </a:effectLst>
-        </p:spPr>
-        <p:style>
-          <a:lnRef idx="2">
-            <a:schemeClr val="accent1">
-              <a:shade val="50000"/>
-            </a:schemeClr>
-          </a:lnRef>
-          <a:fillRef idx="1">
-            <a:schemeClr val="accent1"/>
-          </a:fillRef>
-          <a:effectRef idx="0">
-            <a:schemeClr val="accent1"/>
-          </a:effectRef>
-          <a:fontRef idx="minor">
-            <a:schemeClr val="lt1"/>
-          </a:fontRef>
-        </p:style>
-        <p:txBody>
-          <a:bodyPr rtlCol="0" anchor="ctr"/>
-          <a:lstStyle/>
-          <a:p>
-            <a:pPr marL="0" marR="0" lvl="0" indent="0" algn="ctr" defTabSz="914400" rtl="0" eaLnBrk="1" fontAlgn="auto" latinLnBrk="0" hangingPunct="1">
-              <a:lnSpc>
-                <a:spcPct val="100000"/>
-              </a:lnSpc>
+          <a:noFill/>
+        </p:spPr>
+        <p:txBody>
+          <a:bodyPr wrap="square" lIns="0" tIns="0" rIns="0" bIns="0" anchor="t">
+            <a:noAutofit/>
+          </a:bodyPr>
+          <a:lstStyle/>
+          <a:p>
+            <a:pPr marL="0" indent="0" algn="l">
               <a:spcBef>
                 <a:spcPts val="0"/>
               </a:spcBef>
-              <a:spcAft>
-                <a:spcPts val="0"/>
-              </a:spcAft>
-              <a:buClrTx/>
-              <a:buSzTx/>
-              <a:buFontTx/>
-              <a:buNone/>
-              <a:tabLst/>
-              <a:defRPr/>
+              <a:buNone/>
             </a:pPr>
-            <a:endParaRPr kumimoji="0" lang="en-US" sz="1800" b="0" i="0" u="none" strike="noStrike" kern="1200" cap="none" spc="0" normalizeH="0" baseline="0" noProof="0">
-              <a:ln>
-                <a:noFill/>
-              </a:ln>
-              <a:solidFill>
-                <a:prstClr val="white"/>
-              </a:solidFill>
-              <a:effectLst/>
-              <a:uLnTx/>
-              <a:uFillTx/>
-              <a:latin typeface="Calibri" panose="020F0502020204030204"/>
-              <a:ea typeface="+mn-ea"/>
-              <a:cs typeface="+mn-cs"/>
-            </a:endParaRPr>
-          </a:p>
-        </p:txBody>
-      </p:sp>
-      <p:sp useBgFill="1">
-        <p:nvSpPr>
-          <p:cNvPr id="12" name="Rectangle 11">
-            <a:extLst>
-              <a:ext uri="{FF2B5EF4-FFF2-40B4-BE49-F238E27FC236}">
-                <a16:creationId xmlns:a16="http://schemas.microsoft.com/office/drawing/2014/main" id="{8E0105E7-23DB-4CF2-8258-FF47C7620F6E}"/>
-              </a:ext>
-              <a:ext uri="{C183D7F6-B498-43B3-948B-1728B52AA6E4}">
-                <adec:decorative xmlns:adec="http://schemas.microsoft.com/office/drawing/2017/decorative" val="1"/>
-              </a:ext>
-            </a:extLst>
-          </p:cNvPr>
-          <p:cNvSpPr>
-            <a:spLocks noGrp="1" noRot="1" noChangeAspect="1" noMove="1" noResize="1" noEditPoints="1" noAdjustHandles="1" noChangeArrowheads="1" noChangeShapeType="1" noTextEdit="1"/>
-          </p:cNvSpPr>
-          <p:nvPr>
-            <p:extLst>
-              <p:ext uri="{386F3935-93C4-4BCD-93E2-E3B085C9AB24}">
-                <p16:designElem xmlns:p16="http://schemas.microsoft.com/office/powerpoint/2015/main" val="1"/>
-              </p:ext>
-            </p:extLst>
-          </p:nvPr>
+            <a:r>
+              <a:rPr lang="en-US" sz="1950" b="1" dirty="0">
+                <a:solidFill>
+                  <a:srgbClr val="30669D"/>
+                </a:solidFill>
+                <a:latin typeface="Aptos"/>
+                <a:ea typeface="Aptos"/>
+                <a:cs typeface="Aptos"/>
+              </a:rPr>
+              <a:t>Nodes</a:t>
+            </a:r>
+          </a:p>
+        </p:txBody>
+      </p:sp>
+      <p:sp>
+        <p:nvSpPr>
+          <p:cNvPr id="5" name="Node list"/>
+          <p:cNvSpPr txBox="1"/>
+          <p:nvPr/>
         </p:nvSpPr>
         <p:spPr>
           <a:xfrm>
-            <a:off x="566928" y="0"/>
-            <a:ext cx="11155680" cy="2011680"/>
+            <a:off x="786384" y="2240280"/>
+            <a:ext cx="6309360" cy="4023360"/>
           </a:xfrm>
           <a:prstGeom prst="rect">
             <a:avLst/>
           </a:prstGeom>
-          <a:ln w="9525">
-            <a:noFill/>
-          </a:ln>
-          <a:effectLst/>
-        </p:spPr>
-        <p:style>
-          <a:lnRef idx="2">
-            <a:schemeClr val="accent1">
-              <a:shade val="50000"/>
-            </a:schemeClr>
-          </a:lnRef>
-          <a:fillRef idx="1">
-            <a:schemeClr val="accent1"/>
-          </a:fillRef>
-          <a:effectRef idx="0">
-            <a:schemeClr val="accent1"/>
-          </a:effectRef>
-          <a:fontRef idx="minor">
-            <a:schemeClr val="lt1"/>
-          </a:fontRef>
-        </p:style>
-        <p:txBody>
-          <a:bodyPr rtlCol="0" anchor="ctr"/>
-          <a:lstStyle/>
-          <a:p>
-            <a:pPr marL="0" marR="0" lvl="0" indent="0" algn="ctr" defTabSz="914400" rtl="0" eaLnBrk="1" fontAlgn="auto" latinLnBrk="0" hangingPunct="1">
-              <a:lnSpc>
-                <a:spcPct val="100000"/>
-              </a:lnSpc>
+          <a:noFill/>
+        </p:spPr>
+        <p:txBody>
+          <a:bodyPr wrap="square" lIns="0" tIns="0" rIns="0" bIns="0" anchor="t">
+            <a:noAutofit/>
+          </a:bodyPr>
+          <a:lstStyle/>
+          <a:p>
+            <a:pPr marL="228600" indent="-228600" algn="l">
               <a:spcBef>
                 <a:spcPts val="0"/>
               </a:spcBef>
-              <a:spcAft>
-                <a:spcPts val="0"/>
-              </a:spcAft>
-              <a:buClrTx/>
-              <a:buSzTx/>
-              <a:buFontTx/>
-              <a:buNone/>
-              <a:tabLst/>
-              <a:defRPr/>
+              <a:buClr>
+                <a:srgbClr val="30669D"/>
+              </a:buClr>
+              <a:buFont typeface="Arial"/>
+              <a:buChar char="•"/>
             </a:pPr>
-            <a:endParaRPr kumimoji="0" lang="en-US" sz="1800" b="0" i="0" u="none" strike="noStrike" kern="1200" cap="none" spc="0" normalizeH="0" baseline="0" noProof="0">
-              <a:ln>
-                <a:noFill/>
-              </a:ln>
-              <a:solidFill>
-                <a:prstClr val="white"/>
-              </a:solidFill>
-              <a:effectLst/>
-              <a:uLnTx/>
-              <a:uFillTx/>
-              <a:latin typeface="Calibri" panose="020F0502020204030204"/>
-              <a:ea typeface="+mn-ea"/>
-              <a:cs typeface="+mn-cs"/>
-            </a:endParaRPr>
-          </a:p>
-        </p:txBody>
-      </p:sp>
-      <p:sp>
-        <p:nvSpPr>
-          <p:cNvPr id="2" name="Title 1">
-            <a:extLst>
-              <a:ext uri="{FF2B5EF4-FFF2-40B4-BE49-F238E27FC236}">
-                <a16:creationId xmlns:a16="http://schemas.microsoft.com/office/drawing/2014/main" id="{2698BF27-BBAE-92E8-1203-24CC45367720}"/>
-              </a:ext>
-            </a:extLst>
-          </p:cNvPr>
-          <p:cNvSpPr>
-            <a:spLocks noGrp="1"/>
-          </p:cNvSpPr>
-          <p:nvPr>
-            <p:ph type="title"/>
-          </p:nvPr>
+            <a:r>
+              <a:rPr lang="en-US" sz="1600" b="1" dirty="0">
+                <a:solidFill>
+                  <a:srgbClr val="000000"/>
+                </a:solidFill>
+                <a:latin typeface="Aptos"/>
+                <a:ea typeface="Aptos"/>
+                <a:cs typeface="Aptos"/>
+              </a:rPr>
+              <a:t>Camera: </a:t>
+            </a:r>
+            <a:r>
+              <a:rPr lang="en-US" sz="1600" b="0" dirty="0">
+                <a:solidFill>
+                  <a:srgbClr val="000000"/>
+                </a:solidFill>
+                <a:latin typeface="Aptos"/>
+                <a:ea typeface="Aptos"/>
+                <a:cs typeface="Aptos"/>
+              </a:rPr>
+              <a:t>streams video from the Pi Camera Module 3</a:t>
+            </a:r>
+          </a:p>
+          <a:p>
+            <a:pPr marL="228600" indent="-228600" algn="l">
+              <a:spcBef>
+                <a:spcPts val="700"/>
+              </a:spcBef>
+              <a:buClr>
+                <a:srgbClr val="30669D"/>
+              </a:buClr>
+              <a:buFont typeface="Arial"/>
+              <a:buChar char="•"/>
+            </a:pPr>
+            <a:r>
+              <a:rPr lang="en-US" sz="1600" b="1" dirty="0">
+                <a:solidFill>
+                  <a:srgbClr val="000000"/>
+                </a:solidFill>
+                <a:latin typeface="Aptos"/>
+                <a:ea typeface="Aptos"/>
+                <a:cs typeface="Aptos"/>
+              </a:rPr>
+              <a:t>Sign detector: </a:t>
+            </a:r>
+            <a:r>
+              <a:rPr lang="en-US" sz="1600" b="0" dirty="0">
+                <a:solidFill>
+                  <a:srgbClr val="000000"/>
+                </a:solidFill>
+                <a:latin typeface="Aptos"/>
+                <a:ea typeface="Aptos"/>
+                <a:cs typeface="Aptos"/>
+              </a:rPr>
+              <a:t>runs the vision model and reports each sign’s type, confidence and position</a:t>
+            </a:r>
+          </a:p>
+          <a:p>
+            <a:pPr marL="228600" indent="-228600" algn="l">
+              <a:spcBef>
+                <a:spcPts val="700"/>
+              </a:spcBef>
+              <a:buClr>
+                <a:srgbClr val="30669D"/>
+              </a:buClr>
+              <a:buFont typeface="Arial"/>
+              <a:buChar char="•"/>
+            </a:pPr>
+            <a:r>
+              <a:rPr lang="en-US" sz="1600" b="1" dirty="0">
+                <a:solidFill>
+                  <a:srgbClr val="000000"/>
+                </a:solidFill>
+                <a:latin typeface="Aptos"/>
+                <a:ea typeface="Aptos"/>
+                <a:cs typeface="Aptos"/>
+              </a:rPr>
+              <a:t>Line sensor: </a:t>
+            </a:r>
+            <a:r>
+              <a:rPr lang="en-US" sz="1600" b="0" dirty="0">
+                <a:solidFill>
+                  <a:srgbClr val="000000"/>
+                </a:solidFill>
+                <a:latin typeface="Aptos"/>
+                <a:ea typeface="Aptos"/>
+                <a:cs typeface="Aptos"/>
+              </a:rPr>
+              <a:t>tracks the lane lines with TCRT5000 IR sensors</a:t>
+            </a:r>
+          </a:p>
+          <a:p>
+            <a:pPr marL="228600" indent="-228600" algn="l">
+              <a:spcBef>
+                <a:spcPts val="700"/>
+              </a:spcBef>
+              <a:buClr>
+                <a:srgbClr val="30669D"/>
+              </a:buClr>
+              <a:buFont typeface="Arial"/>
+              <a:buChar char="•"/>
+            </a:pPr>
+            <a:r>
+              <a:rPr lang="en-US" sz="1600" b="1" dirty="0">
+                <a:solidFill>
+                  <a:srgbClr val="000000"/>
+                </a:solidFill>
+                <a:latin typeface="Aptos"/>
+                <a:ea typeface="Aptos"/>
+                <a:cs typeface="Aptos"/>
+              </a:rPr>
+              <a:t>IMU: </a:t>
+            </a:r>
+            <a:r>
+              <a:rPr lang="en-US" sz="1600" b="0" dirty="0">
+                <a:solidFill>
+                  <a:srgbClr val="000000"/>
+                </a:solidFill>
+                <a:latin typeface="Aptos"/>
+                <a:ea typeface="Aptos"/>
+                <a:cs typeface="Aptos"/>
+              </a:rPr>
+              <a:t>reports turning and motion; detects if the car is stuck</a:t>
+            </a:r>
+          </a:p>
+          <a:p>
+            <a:pPr marL="228600" indent="-228600" algn="l">
+              <a:spcBef>
+                <a:spcPts val="700"/>
+              </a:spcBef>
+              <a:buClr>
+                <a:srgbClr val="30669D"/>
+              </a:buClr>
+              <a:buFont typeface="Arial"/>
+              <a:buChar char="•"/>
+            </a:pPr>
+            <a:r>
+              <a:rPr lang="en-US" sz="1600" b="1" dirty="0">
+                <a:solidFill>
+                  <a:srgbClr val="000000"/>
+                </a:solidFill>
+                <a:latin typeface="Aptos"/>
+                <a:ea typeface="Aptos"/>
+                <a:cs typeface="Aptos"/>
+              </a:rPr>
+              <a:t>Behavior: </a:t>
+            </a:r>
+            <a:r>
+              <a:rPr lang="en-US" sz="1600" b="0" dirty="0">
+                <a:solidFill>
+                  <a:srgbClr val="000000"/>
+                </a:solidFill>
+                <a:latin typeface="Aptos"/>
+                <a:ea typeface="Aptos"/>
+                <a:cs typeface="Aptos"/>
+              </a:rPr>
+              <a:t>a state machine that turns signs, lane position and IMU data into driving decisions</a:t>
+            </a:r>
+          </a:p>
+          <a:p>
+            <a:pPr marL="228600" indent="-228600" algn="l">
+              <a:spcBef>
+                <a:spcPts val="700"/>
+              </a:spcBef>
+              <a:buClr>
+                <a:srgbClr val="30669D"/>
+              </a:buClr>
+              <a:buFont typeface="Arial"/>
+              <a:buChar char="•"/>
+            </a:pPr>
+            <a:r>
+              <a:rPr lang="en-US" sz="1600" b="1" dirty="0">
+                <a:solidFill>
+                  <a:srgbClr val="000000"/>
+                </a:solidFill>
+                <a:latin typeface="Aptos"/>
+                <a:ea typeface="Aptos"/>
+                <a:cs typeface="Aptos"/>
+              </a:rPr>
+              <a:t>Motor driver: </a:t>
+            </a:r>
+            <a:r>
+              <a:rPr lang="en-US" sz="1600" b="0" dirty="0">
+                <a:solidFill>
+                  <a:srgbClr val="000000"/>
+                </a:solidFill>
+                <a:latin typeface="Aptos"/>
+                <a:ea typeface="Aptos"/>
+                <a:cs typeface="Aptos"/>
+              </a:rPr>
+              <a:t>drives the wheels through the Waveshare HAT and stops if commands stop arriving</a:t>
+            </a:r>
+          </a:p>
+          <a:p>
+            <a:pPr marL="228600" indent="-228600" algn="l">
+              <a:spcBef>
+                <a:spcPts val="700"/>
+              </a:spcBef>
+              <a:buClr>
+                <a:srgbClr val="30669D"/>
+              </a:buClr>
+              <a:buFont typeface="Arial"/>
+              <a:buChar char="•"/>
+            </a:pPr>
+            <a:r>
+              <a:rPr lang="en-US" sz="1600" b="1" dirty="0">
+                <a:solidFill>
+                  <a:srgbClr val="000000"/>
+                </a:solidFill>
+                <a:latin typeface="Aptos"/>
+                <a:ea typeface="Aptos"/>
+                <a:cs typeface="Aptos"/>
+              </a:rPr>
+              <a:t>LCD: </a:t>
+            </a:r>
+            <a:r>
+              <a:rPr lang="en-US" sz="1600" b="0" dirty="0">
+                <a:solidFill>
+                  <a:srgbClr val="000000"/>
+                </a:solidFill>
+                <a:latin typeface="Aptos"/>
+                <a:ea typeface="Aptos"/>
+                <a:cs typeface="Aptos"/>
+              </a:rPr>
+              <a:t>shows the car’s state and the last sign detected</a:t>
+            </a:r>
+          </a:p>
+          <a:p>
+            <a:pPr marL="228600" indent="-228600" algn="l">
+              <a:spcBef>
+                <a:spcPts val="700"/>
+              </a:spcBef>
+              <a:buClr>
+                <a:srgbClr val="30669D"/>
+              </a:buClr>
+              <a:buFont typeface="Arial"/>
+              <a:buChar char="•"/>
+            </a:pPr>
+            <a:r>
+              <a:rPr lang="en-US" sz="1600" b="1" dirty="0">
+                <a:solidFill>
+                  <a:srgbClr val="000000"/>
+                </a:solidFill>
+                <a:latin typeface="Aptos"/>
+                <a:ea typeface="Aptos"/>
+                <a:cs typeface="Aptos"/>
+              </a:rPr>
+              <a:t>Teleop: </a:t>
+            </a:r>
+            <a:r>
+              <a:rPr lang="en-US" sz="1600" b="0" dirty="0">
+                <a:solidFill>
+                  <a:srgbClr val="000000"/>
+                </a:solidFill>
+                <a:latin typeface="Aptos"/>
+                <a:ea typeface="Aptos"/>
+                <a:cs typeface="Aptos"/>
+              </a:rPr>
+              <a:t>lets a person take over and drive manually</a:t>
+            </a:r>
+          </a:p>
+        </p:txBody>
+      </p:sp>
+      <p:sp>
+        <p:nvSpPr>
+          <p:cNvPr id="6" name="Why ROS 2"/>
+          <p:cNvSpPr txBox="1"/>
+          <p:nvPr/>
         </p:nvSpPr>
         <p:spPr>
           <a:xfrm>
-            <a:off x="1115568" y="548640"/>
-            <a:ext cx="10168128" cy="1179576"/>
-          </a:xfrm>
-        </p:spPr>
-        <p:txBody>
-          <a:bodyPr>
-            <a:normAutofit/>
-          </a:bodyPr>
-          <a:lstStyle/>
-          <a:p>
-            <a:r>
-              <a:rPr lang="en-US" sz="4000"/>
-              <a:t>ROS 2 Implementation</a:t>
-            </a:r>
-          </a:p>
-        </p:txBody>
-      </p:sp>
-      <p:sp>
-        <p:nvSpPr>
-          <p:cNvPr id="14" name="Rectangle 13">
-            <a:extLst>
-              <a:ext uri="{FF2B5EF4-FFF2-40B4-BE49-F238E27FC236}">
-                <a16:creationId xmlns:a16="http://schemas.microsoft.com/office/drawing/2014/main" id="{074B4F7D-14B2-478B-8BF5-01E4E0C5D263}"/>
-              </a:ext>
-              <a:ext uri="{C183D7F6-B498-43B3-948B-1728B52AA6E4}">
-                <adec:decorative xmlns:adec="http://schemas.microsoft.com/office/drawing/2017/decorative" val="1"/>
-              </a:ext>
-            </a:extLst>
-          </p:cNvPr>
-          <p:cNvSpPr>
-            <a:spLocks noGrp="1" noRot="1" noChangeAspect="1" noMove="1" noResize="1" noEditPoints="1" noAdjustHandles="1" noChangeArrowheads="1" noChangeShapeType="1" noTextEdit="1"/>
-          </p:cNvSpPr>
-          <p:nvPr>
-            <p:extLst>
-              <p:ext uri="{386F3935-93C4-4BCD-93E2-E3B085C9AB24}">
-                <p16:designElem xmlns:p16="http://schemas.microsoft.com/office/powerpoint/2015/main" val="1"/>
-              </p:ext>
-            </p:extLst>
-          </p:nvPr>
-        </p:nvSpPr>
-        <p:spPr>
-          <a:xfrm>
-            <a:off x="498834" y="758952"/>
-            <a:ext cx="128016" cy="704088"/>
+            <a:off x="7635240" y="1719072"/>
+            <a:ext cx="3794760" cy="384048"/>
           </a:xfrm>
           <a:prstGeom prst="rect">
             <a:avLst/>
           </a:prstGeom>
-          <a:solidFill>
-            <a:schemeClr val="accent2"/>
-          </a:solidFill>
-          <a:ln>
-            <a:noFill/>
-          </a:ln>
-        </p:spPr>
-        <p:style>
-          <a:lnRef idx="2">
-            <a:schemeClr val="accent1">
-              <a:shade val="50000"/>
-            </a:schemeClr>
-          </a:lnRef>
-          <a:fillRef idx="1">
-            <a:schemeClr val="accent1"/>
-          </a:fillRef>
-          <a:effectRef idx="0">
-            <a:schemeClr val="accent1"/>
-          </a:effectRef>
-          <a:fontRef idx="minor">
-            <a:schemeClr val="lt1"/>
-          </a:fontRef>
-        </p:style>
-        <p:txBody>
-          <a:bodyPr rtlCol="0" anchor="ctr"/>
-          <a:lstStyle/>
-          <a:p>
-            <a:pPr algn="ctr"/>
-            <a:endParaRPr lang="en-US">
-              <a:solidFill>
-                <a:prstClr val="white"/>
-              </a:solidFill>
-              <a:latin typeface="Calibri" panose="020F0502020204030204"/>
-            </a:endParaRPr>
-          </a:p>
-        </p:txBody>
-      </p:sp>
-      <p:sp>
-        <p:nvSpPr>
-          <p:cNvPr id="3" name="Content Placeholder 2">
-            <a:extLst>
-              <a:ext uri="{FF2B5EF4-FFF2-40B4-BE49-F238E27FC236}">
-                <a16:creationId xmlns:a16="http://schemas.microsoft.com/office/drawing/2014/main" id="{BD450EBB-D982-FD85-D489-3D6B4BBFF526}"/>
-              </a:ext>
-            </a:extLst>
-          </p:cNvPr>
-          <p:cNvSpPr>
-            <a:spLocks noGrp="1"/>
-          </p:cNvSpPr>
-          <p:nvPr>
-            <p:ph idx="1"/>
-          </p:nvPr>
+          <a:noFill/>
+        </p:spPr>
+        <p:txBody>
+          <a:bodyPr wrap="square" lIns="0" tIns="0" rIns="0" bIns="0" anchor="t">
+            <a:noAutofit/>
+          </a:bodyPr>
+          <a:lstStyle/>
+          <a:p>
+            <a:pPr marL="0" indent="0" algn="l">
+              <a:spcBef>
+                <a:spcPts val="0"/>
+              </a:spcBef>
+              <a:buNone/>
+            </a:pPr>
+            <a:r>
+              <a:rPr lang="en-US" sz="1950" b="1" dirty="0">
+                <a:solidFill>
+                  <a:srgbClr val="30669D"/>
+                </a:solidFill>
+                <a:latin typeface="Aptos"/>
+                <a:ea typeface="Aptos"/>
+                <a:cs typeface="Aptos"/>
+              </a:rPr>
+              <a:t>Why ROS 2</a:t>
+            </a:r>
+          </a:p>
+        </p:txBody>
+      </p:sp>
+      <p:sp>
+        <p:nvSpPr>
+          <p:cNvPr id="7" name="Why ROS 2 list"/>
+          <p:cNvSpPr txBox="1"/>
+          <p:nvPr/>
         </p:nvSpPr>
         <p:spPr>
           <a:xfrm>
-            <a:off x="1115568" y="2481943"/>
-            <a:ext cx="10168128" cy="3695020"/>
-          </a:xfrm>
-        </p:spPr>
-        <p:txBody>
-          <a:bodyPr>
-            <a:normAutofit fontScale="70000" lnSpcReduction="20000"/>
+            <a:off x="7635240" y="2240280"/>
+            <a:ext cx="3794760" cy="2103120"/>
+          </a:xfrm>
+          <a:prstGeom prst="rect">
+            <a:avLst/>
+          </a:prstGeom>
+          <a:noFill/>
+        </p:spPr>
+        <p:txBody>
+          <a:bodyPr wrap="square" lIns="0" tIns="0" rIns="0" bIns="0" anchor="t">
+            <a:noAutofit/>
           </a:bodyPr>
           <a:lstStyle/>
           <a:p>
-            <a:pPr marL="0" indent="0">
-              <a:buNone/>
+            <a:pPr marL="228600" indent="-228600" algn="l">
+              <a:spcBef>
+                <a:spcPts val="0"/>
+              </a:spcBef>
+              <a:buClr>
+                <a:srgbClr val="30669D"/>
+              </a:buClr>
+              <a:buFont typeface="Arial"/>
+              <a:buChar char="•"/>
             </a:pPr>
             <a:r>
-              <a:rPr lang="en-US" sz="2200" dirty="0"/>
-              <a:t>What I have learned so far is that it could be possible to make ROS 2 into our pipeline, but it will take more upfront work.</a:t>
-            </a:r>
-          </a:p>
-          <a:p>
-            <a:pPr marL="0" indent="0">
-              <a:buNone/>
+              <a:rPr lang="en-US" sz="1600" b="0" dirty="0">
+                <a:solidFill>
+                  <a:srgbClr val="000000"/>
+                </a:solidFill>
+                <a:latin typeface="Aptos"/>
+                <a:ea typeface="Aptos"/>
+                <a:cs typeface="Aptos"/>
+              </a:rPr>
+              <a:t>Each teammate can own a node without touching the others</a:t>
+            </a:r>
+          </a:p>
+          <a:p>
+            <a:pPr marL="228600" indent="-228600" algn="l">
+              <a:spcBef>
+                <a:spcPts val="900"/>
+              </a:spcBef>
+              <a:buClr>
+                <a:srgbClr val="30669D"/>
+              </a:buClr>
+              <a:buFont typeface="Arial"/>
+              <a:buChar char="•"/>
             </a:pPr>
             <a:r>
-              <a:rPr lang="en-US" sz="2200" dirty="0"/>
-              <a:t>The preliminary idea of a node structure</a:t>
-            </a:r>
-          </a:p>
-          <a:p>
-            <a:r>
-              <a:rPr lang="en-US" sz="2200" dirty="0"/>
-              <a:t>Camera node: Streams live video from the Pi Camera Module 3, with autofocus</a:t>
-            </a:r>
-          </a:p>
-          <a:p>
-            <a:r>
-              <a:rPr lang="en-US" sz="2200" dirty="0"/>
-              <a:t>Sign detector node: Runs the vision model on each frame and reports every sign’s type, confidence and position</a:t>
-            </a:r>
-          </a:p>
-          <a:p>
-            <a:r>
-              <a:rPr lang="en-US" sz="2200" dirty="0"/>
-              <a:t>IMU node: Reports the car’s turning and motion, and detects when it’s stuck</a:t>
-            </a:r>
-          </a:p>
-          <a:p>
-            <a:r>
-              <a:rPr lang="en-US" sz="2200" dirty="0"/>
-              <a:t>Behavior node: A state machine that combines sign detections and IMU data into driving decisions (stop, slow down, turn)</a:t>
-            </a:r>
-          </a:p>
-          <a:p>
-            <a:r>
-              <a:rPr lang="en-US" sz="2200" dirty="0"/>
-              <a:t>Motor driver node: Turns speed and steering commands into wheel power through the </a:t>
-            </a:r>
-            <a:r>
-              <a:rPr lang="en-US" sz="2200" dirty="0" err="1"/>
-              <a:t>Waveshare</a:t>
-            </a:r>
-            <a:r>
-              <a:rPr lang="en-US" sz="2200" dirty="0"/>
-              <a:t> Motor Driver HAT, and stops the motors automatically if commands stop arriving</a:t>
-            </a:r>
-          </a:p>
-          <a:p>
-            <a:r>
-              <a:rPr lang="en-US" sz="2200" dirty="0"/>
-              <a:t>LCD node: Shows the car’s current state and the last sign it detected</a:t>
-            </a:r>
-          </a:p>
-          <a:p>
-            <a:r>
-              <a:rPr lang="en-US" sz="2200" dirty="0" err="1"/>
-              <a:t>Teleop</a:t>
-            </a:r>
-            <a:r>
-              <a:rPr lang="en-US" sz="2200" dirty="0"/>
-              <a:t> node: Lets a person take over and drive the car manually</a:t>
-            </a:r>
-          </a:p>
-          <a:p>
-            <a:pPr marL="0" indent="0">
-              <a:buNone/>
+              <a:rPr lang="en-US" sz="1600" b="0" dirty="0">
+                <a:solidFill>
+                  <a:srgbClr val="000000"/>
+                </a:solidFill>
+                <a:latin typeface="Aptos"/>
+                <a:ea typeface="Aptos"/>
+                <a:cs typeface="Aptos"/>
+              </a:rPr>
+              <a:t>Recorded drives can be replayed to test without the car</a:t>
+            </a:r>
+          </a:p>
+          <a:p>
+            <a:pPr marL="228600" indent="-228600" algn="l">
+              <a:spcBef>
+                <a:spcPts val="900"/>
+              </a:spcBef>
+              <a:buClr>
+                <a:srgbClr val="30669D"/>
+              </a:buClr>
+              <a:buFont typeface="Arial"/>
+              <a:buChar char="•"/>
             </a:pPr>
             <a:r>
-              <a:rPr lang="en-US" sz="2200" dirty="0"/>
-              <a:t>Safety: Motors stop automatically if commands stop arriving, and a manual override is available</a:t>
-            </a:r>
-          </a:p>
-          <a:p>
-            <a:pPr marL="0" indent="0">
+              <a:rPr lang="en-US" sz="1600" b="0" dirty="0">
+                <a:solidFill>
+                  <a:srgbClr val="000000"/>
+                </a:solidFill>
+                <a:latin typeface="Aptos"/>
+                <a:ea typeface="Aptos"/>
+                <a:cs typeface="Aptos"/>
+              </a:rPr>
+              <a:t>Laptops can watch the camera feed and topics live</a:t>
+            </a:r>
+          </a:p>
+        </p:txBody>
+      </p:sp>
+      <p:sp>
+        <p:nvSpPr>
+          <p:cNvPr id="8" name="Trade-off"/>
+          <p:cNvSpPr txBox="1"/>
+          <p:nvPr/>
+        </p:nvSpPr>
+        <p:spPr>
+          <a:xfrm>
+            <a:off x="7635240" y="4434840"/>
+            <a:ext cx="3794760" cy="384048"/>
+          </a:xfrm>
+          <a:prstGeom prst="rect">
+            <a:avLst/>
+          </a:prstGeom>
+          <a:noFill/>
+        </p:spPr>
+        <p:txBody>
+          <a:bodyPr wrap="square" lIns="0" tIns="0" rIns="0" bIns="0" anchor="t">
+            <a:noAutofit/>
+          </a:bodyPr>
+          <a:lstStyle/>
+          <a:p>
+            <a:pPr marL="0" indent="0" algn="l">
+              <a:spcBef>
+                <a:spcPts val="0"/>
+              </a:spcBef>
               <a:buNone/>
             </a:pPr>
             <a:r>
-              <a:rPr lang="en-US" sz="2200" dirty="0"/>
-              <a:t>Why ROS 2: Modular nodes split the work across the team, and recorded drives can be replayed to test without the car</a:t>
+              <a:rPr lang="en-US" sz="1950" b="1" dirty="0">
+                <a:solidFill>
+                  <a:srgbClr val="30669D"/>
+                </a:solidFill>
+                <a:latin typeface="Aptos"/>
+                <a:ea typeface="Aptos"/>
+                <a:cs typeface="Aptos"/>
+              </a:rPr>
+              <a:t>Trade-off</a:t>
+            </a:r>
+          </a:p>
+        </p:txBody>
+      </p:sp>
+      <p:sp>
+        <p:nvSpPr>
+          <p:cNvPr id="9" name="Trade-off text"/>
+          <p:cNvSpPr txBox="1"/>
+          <p:nvPr/>
+        </p:nvSpPr>
+        <p:spPr>
+          <a:xfrm>
+            <a:off x="7635240" y="4956048"/>
+            <a:ext cx="3794760" cy="1280160"/>
+          </a:xfrm>
+          <a:prstGeom prst="rect">
+            <a:avLst/>
+          </a:prstGeom>
+          <a:noFill/>
+        </p:spPr>
+        <p:txBody>
+          <a:bodyPr wrap="square" lIns="0" tIns="0" rIns="0" bIns="0" anchor="t">
+            <a:noAutofit/>
+          </a:bodyPr>
+          <a:lstStyle/>
+          <a:p>
+            <a:pPr marL="0" indent="0" algn="l">
+              <a:spcBef>
+                <a:spcPts val="0"/>
+              </a:spcBef>
+              <a:buNone/>
+            </a:pPr>
+            <a:r>
+              <a:rPr lang="en-US" sz="1600" b="0" dirty="0">
+                <a:solidFill>
+                  <a:srgbClr val="000000"/>
+                </a:solidFill>
+                <a:latin typeface="Aptos"/>
+                <a:ea typeface="Aptos"/>
+                <a:cs typeface="Aptos"/>
+              </a:rPr>
+              <a:t>More upfront setup than a single script, including a custom Docker build for the CM5 camera</a:t>
             </a:r>
           </a:p>
         </p:txBody>
       </p:sp>
     </p:spTree>
-    <p:extLst>
-      <p:ext uri="{BB962C8B-B14F-4D97-AF65-F5344CB8AC3E}">
-        <p14:creationId xmlns:p14="http://schemas.microsoft.com/office/powerpoint/2010/main" val="1476949509"/>
-      </p:ext>
-    </p:extLst>
   </p:cSld>
   <p:clrMapOvr>
     <a:masterClrMapping/>
@@ -3973,14 +4138,6 @@
 <file path=ppt/slides/slide3.xml><?xml version="1.0" encoding="utf-8"?>
 <p:sld xmlns:a="http://schemas.openxmlformats.org/drawingml/2006/main" xmlns:r="http://schemas.openxmlformats.org/officeDocument/2006/relationships" xmlns:p="http://schemas.openxmlformats.org/presentationml/2006/main">
   <p:cSld>
-    <p:bg>
-      <p:bgPr>
-        <a:solidFill>
-          <a:schemeClr val="bg1"/>
-        </a:solidFill>
-        <a:effectLst/>
-      </p:bgPr>
-    </p:bg>
     <p:spTree>
       <p:nvGrpSpPr>
         <p:cNvPr id="1" name=""/>
@@ -3995,614 +4152,1048 @@
           <a:chExt cx="0" cy="0"/>
         </a:xfrm>
       </p:grpSpPr>
-      <p:sp useBgFill="1">
-        <p:nvSpPr>
-          <p:cNvPr id="25" name="Rectangle 24">
-            <a:extLst>
-              <a:ext uri="{FF2B5EF4-FFF2-40B4-BE49-F238E27FC236}">
-                <a16:creationId xmlns:a16="http://schemas.microsoft.com/office/drawing/2014/main" id="{7979CB03-77A3-48F2-A1C8-52F03FCB3D00}"/>
-              </a:ext>
-              <a:ext uri="{C183D7F6-B498-43B3-948B-1728B52AA6E4}">
-                <adec:decorative xmlns:adec="http://schemas.microsoft.com/office/drawing/2017/decorative" val="1"/>
-              </a:ext>
-            </a:extLst>
-          </p:cNvPr>
-          <p:cNvSpPr>
-            <a:spLocks noGrp="1" noRot="1" noChangeAspect="1" noMove="1" noResize="1" noEditPoints="1" noAdjustHandles="1" noChangeArrowheads="1" noChangeShapeType="1" noTextEdit="1"/>
-          </p:cNvSpPr>
-          <p:nvPr>
-            <p:extLst>
-              <p:ext uri="{386F3935-93C4-4BCD-93E2-E3B085C9AB24}">
-                <p16:designElem xmlns:p16="http://schemas.microsoft.com/office/powerpoint/2015/main" val="1"/>
-              </p:ext>
-            </p:extLst>
+      <p:sp>
+        <p:nvSpPr>
+          <p:cNvPr id="2" name="Title"/>
+          <p:cNvSpPr>
+            <a:spLocks noGrp="1"/>
+          </p:cNvSpPr>
+          <p:nvPr>
+            <p:ph type="title"/>
           </p:nvPr>
         </p:nvSpPr>
         <p:spPr>
           <a:xfrm>
-            <a:off x="0" y="0"/>
-            <a:ext cx="12192000" cy="6858000"/>
+            <a:off x="768096" y="365760"/>
+            <a:ext cx="10789920" cy="658368"/>
+          </a:xfrm>
+        </p:spPr>
+        <p:txBody>
+          <a:bodyPr lIns="0" tIns="0" rIns="0" bIns="0" anchor="b">
+            <a:normAutofit/>
+          </a:bodyPr>
+          <a:lstStyle/>
+          <a:p>
+            <a:pPr algn="l"/>
+            <a:r>
+              <a:rPr lang="en-US" sz="3500" b="0" dirty="0">
+                <a:solidFill>
+                  <a:srgbClr val="000000"/>
+                </a:solidFill>
+                <a:latin typeface="Aptos Display"/>
+                <a:ea typeface="Aptos Display"/>
+                <a:cs typeface="Aptos Display"/>
+              </a:rPr>
+              <a:t>The behavior node makes every driving decision</a:t>
+            </a:r>
+          </a:p>
+        </p:txBody>
+      </p:sp>
+      <p:sp>
+        <p:nvSpPr>
+          <p:cNvPr id="3" name="Subtitle"/>
+          <p:cNvSpPr txBox="1"/>
+          <p:nvPr/>
+        </p:nvSpPr>
+        <p:spPr>
+          <a:xfrm>
+            <a:off x="786384" y="1024128"/>
+            <a:ext cx="10607040" cy="365760"/>
           </a:xfrm>
           <a:prstGeom prst="rect">
             <a:avLst/>
           </a:prstGeom>
-          <a:ln>
-            <a:noFill/>
+          <a:noFill/>
+        </p:spPr>
+        <p:txBody>
+          <a:bodyPr wrap="square" lIns="0" tIns="0" rIns="0" bIns="0" anchor="t">
+            <a:noAutofit/>
+          </a:bodyPr>
+          <a:lstStyle/>
+          <a:p>
+            <a:pPr marL="0" indent="0" algn="l">
+              <a:spcBef>
+                <a:spcPts val="0"/>
+              </a:spcBef>
+              <a:buNone/>
+            </a:pPr>
+            <a:r>
+              <a:rPr lang="en-US" sz="1500" b="1" dirty="0">
+                <a:solidFill>
+                  <a:srgbClr val="000000"/>
+                </a:solidFill>
+                <a:latin typeface="Aptos"/>
+                <a:ea typeface="Aptos"/>
+                <a:cs typeface="Aptos"/>
+              </a:rPr>
+              <a:t>Draft ROS 2 data flow: boxes are nodes, arrows are topics</a:t>
+            </a:r>
+          </a:p>
+        </p:txBody>
+      </p:sp>
+      <p:sp>
+        <p:nvSpPr>
+          <p:cNvPr id="4" name="Line sensor"/>
+          <p:cNvSpPr/>
+          <p:nvPr/>
+        </p:nvSpPr>
+        <p:spPr>
+          <a:xfrm>
+            <a:off x="6766560" y="1691640"/>
+            <a:ext cx="1920240" cy="841248"/>
+          </a:xfrm>
+          <a:prstGeom prst="roundRect">
+            <a:avLst>
+              <a:gd name="adj" fmla="val 12000"/>
+            </a:avLst>
+          </a:prstGeom>
+          <a:solidFill>
+            <a:srgbClr val="F3F5F7"/>
+          </a:solidFill>
+          <a:ln w="12700">
+            <a:solidFill>
+              <a:srgbClr val="C9D1DA"/>
+            </a:solidFill>
           </a:ln>
         </p:spPr>
-        <p:style>
-          <a:lnRef idx="2">
-            <a:schemeClr val="accent1">
-              <a:shade val="50000"/>
-            </a:schemeClr>
-          </a:lnRef>
-          <a:fillRef idx="1">
-            <a:schemeClr val="accent1"/>
-          </a:fillRef>
-          <a:effectRef idx="0">
-            <a:schemeClr val="accent1"/>
-          </a:effectRef>
-          <a:fontRef idx="minor">
-            <a:schemeClr val="lt1"/>
-          </a:fontRef>
-        </p:style>
-        <p:txBody>
-          <a:bodyPr rtlCol="0" anchor="ctr"/>
+        <p:txBody>
+          <a:bodyPr wrap="square" lIns="45720" tIns="45720" rIns="45720" bIns="45720" anchor="ctr">
+            <a:noAutofit/>
+          </a:bodyPr>
           <a:lstStyle/>
           <a:p>
             <a:pPr algn="ctr"/>
-            <a:endParaRPr lang="en-US"/>
-          </a:p>
-        </p:txBody>
-      </p:sp>
-      <p:sp useBgFill="1">
-        <p:nvSpPr>
-          <p:cNvPr id="27" name="Rectangle 26">
-            <a:extLst>
-              <a:ext uri="{FF2B5EF4-FFF2-40B4-BE49-F238E27FC236}">
-                <a16:creationId xmlns:a16="http://schemas.microsoft.com/office/drawing/2014/main" id="{9073D962-D3D2-4A72-8593-65C213CBFFC3}"/>
-              </a:ext>
-              <a:ext uri="{C183D7F6-B498-43B3-948B-1728B52AA6E4}">
-                <adec:decorative xmlns:adec="http://schemas.microsoft.com/office/drawing/2017/decorative" val="1"/>
-              </a:ext>
-            </a:extLst>
-          </p:cNvPr>
-          <p:cNvSpPr>
-            <a:spLocks noGrp="1" noRot="1" noChangeAspect="1" noMove="1" noResize="1" noEditPoints="1" noAdjustHandles="1" noChangeArrowheads="1" noChangeShapeType="1" noTextEdit="1"/>
-          </p:cNvSpPr>
-          <p:nvPr>
-            <p:extLst>
-              <p:ext uri="{386F3935-93C4-4BCD-93E2-E3B085C9AB24}">
-                <p16:designElem xmlns:p16="http://schemas.microsoft.com/office/powerpoint/2015/main" val="1"/>
-              </p:ext>
-            </p:extLst>
-          </p:nvPr>
-        </p:nvSpPr>
+            <a:r>
+              <a:rPr lang="en-US" sz="1600" b="1" dirty="0">
+                <a:solidFill>
+                  <a:srgbClr val="22313F"/>
+                </a:solidFill>
+                <a:latin typeface="Aptos"/>
+                <a:ea typeface="Aptos"/>
+                <a:cs typeface="Aptos"/>
+              </a:rPr>
+              <a:t>Line sensor</a:t>
+            </a:r>
+          </a:p>
+          <a:p>
+            <a:pPr algn="ctr"/>
+            <a:r>
+              <a:rPr lang="en-US" sz="1200" b="0" dirty="0">
+                <a:solidFill>
+                  <a:srgbClr val="5B6773"/>
+                </a:solidFill>
+                <a:latin typeface="Aptos"/>
+                <a:ea typeface="Aptos"/>
+                <a:cs typeface="Aptos"/>
+              </a:rPr>
+              <a:t>TCRT5000 IR sensors</a:t>
+            </a:r>
+          </a:p>
+        </p:txBody>
+      </p:sp>
+      <p:cxnSp>
+        <p:nvCxnSpPr>
+          <p:cNvPr id="5" name="Arrow /lane"/>
+          <p:cNvCxnSpPr/>
+          <p:nvPr/>
+        </p:nvCxnSpPr>
         <p:spPr>
           <a:xfrm>
-            <a:off x="381654" y="633619"/>
-            <a:ext cx="4520912" cy="5495925"/>
+            <a:off x="7726680" y="2578608"/>
+            <a:ext cx="0" cy="530352"/>
+          </a:xfrm>
+          <a:prstGeom prst="straightConnector1">
+            <a:avLst/>
+          </a:prstGeom>
+          <a:ln w="19050">
+            <a:solidFill>
+              <a:srgbClr val="5B6773"/>
+            </a:solidFill>
+            <a:tailEnd type="triangle" w="med" len="med"/>
+          </a:ln>
+        </p:spPr>
+      </p:cxnSp>
+      <p:sp>
+        <p:nvSpPr>
+          <p:cNvPr id="6" name="Topic /lane"/>
+          <p:cNvSpPr txBox="1"/>
+          <p:nvPr/>
+        </p:nvSpPr>
+        <p:spPr>
+          <a:xfrm>
+            <a:off x="7836408" y="2706624"/>
+            <a:ext cx="914400" cy="274320"/>
           </a:xfrm>
           <a:prstGeom prst="rect">
             <a:avLst/>
           </a:prstGeom>
-          <a:ln w="9525">
-            <a:solidFill>
-              <a:srgbClr val="DEDEDE"/>
-            </a:solidFill>
-          </a:ln>
-          <a:effectLst>
-            <a:outerShdw blurRad="50800" dist="38100" dir="2700000" algn="tl" rotWithShape="0">
-              <a:schemeClr val="bg1">
-                <a:lumMod val="85000"/>
-                <a:alpha val="50000"/>
-              </a:schemeClr>
-            </a:outerShdw>
-          </a:effectLst>
-        </p:spPr>
-        <p:style>
-          <a:lnRef idx="2">
-            <a:schemeClr val="accent1">
-              <a:shade val="50000"/>
-            </a:schemeClr>
-          </a:lnRef>
-          <a:fillRef idx="1">
-            <a:schemeClr val="accent1"/>
-          </a:fillRef>
-          <a:effectRef idx="0">
-            <a:schemeClr val="accent1"/>
-          </a:effectRef>
-          <a:fontRef idx="minor">
-            <a:schemeClr val="lt1"/>
-          </a:fontRef>
-        </p:style>
-        <p:txBody>
-          <a:bodyPr rtlCol="0" anchor="ctr"/>
-          <a:lstStyle/>
-          <a:p>
-            <a:pPr marL="0" marR="0" lvl="0" indent="0" algn="ctr" defTabSz="914400" rtl="0" eaLnBrk="1" fontAlgn="auto" latinLnBrk="0" hangingPunct="1">
-              <a:lnSpc>
-                <a:spcPct val="100000"/>
-              </a:lnSpc>
+          <a:noFill/>
+        </p:spPr>
+        <p:txBody>
+          <a:bodyPr wrap="square" lIns="0" tIns="0" rIns="0" bIns="0" anchor="ctr">
+            <a:noAutofit/>
+          </a:bodyPr>
+          <a:lstStyle/>
+          <a:p>
+            <a:pPr marL="0" indent="0" algn="l">
               <a:spcBef>
                 <a:spcPts val="0"/>
               </a:spcBef>
-              <a:spcAft>
-                <a:spcPts val="0"/>
-              </a:spcAft>
-              <a:buClrTx/>
-              <a:buSzTx/>
-              <a:buFontTx/>
-              <a:buNone/>
-              <a:tabLst/>
-              <a:defRPr/>
+              <a:buNone/>
             </a:pPr>
-            <a:endParaRPr kumimoji="0" lang="en-US" sz="1800" b="0" i="0" u="none" strike="noStrike" kern="1200" cap="none" spc="0" normalizeH="0" baseline="0" noProof="0">
-              <a:ln>
-                <a:noFill/>
-              </a:ln>
-              <a:solidFill>
-                <a:prstClr val="white"/>
-              </a:solidFill>
-              <a:effectLst/>
-              <a:uLnTx/>
-              <a:uFillTx/>
-              <a:latin typeface="Calibri" panose="020F0502020204030204"/>
-              <a:ea typeface="+mn-ea"/>
-              <a:cs typeface="+mn-cs"/>
-            </a:endParaRPr>
-          </a:p>
-        </p:txBody>
-      </p:sp>
-      <p:sp>
-        <p:nvSpPr>
-          <p:cNvPr id="2" name="Title 1">
-            <a:extLst>
-              <a:ext uri="{FF2B5EF4-FFF2-40B4-BE49-F238E27FC236}">
-                <a16:creationId xmlns:a16="http://schemas.microsoft.com/office/drawing/2014/main" id="{6B50277F-C2E1-025E-B6AB-EA1CA120F3BA}"/>
-              </a:ext>
-            </a:extLst>
-          </p:cNvPr>
-          <p:cNvSpPr>
-            <a:spLocks noGrp="1"/>
-          </p:cNvSpPr>
-          <p:nvPr>
-            <p:ph type="title"/>
-          </p:nvPr>
+            <a:r>
+              <a:rPr lang="en-US" sz="1100" b="0" dirty="0">
+                <a:solidFill>
+                  <a:srgbClr val="5B6773"/>
+                </a:solidFill>
+                <a:latin typeface="Courier New"/>
+                <a:cs typeface="Courier New"/>
+              </a:rPr>
+              <a:t>/lane</a:t>
+            </a:r>
+          </a:p>
+        </p:txBody>
+      </p:sp>
+      <p:sp>
+        <p:nvSpPr>
+          <p:cNvPr id="7" name="Camera"/>
+          <p:cNvSpPr/>
+          <p:nvPr/>
         </p:nvSpPr>
         <p:spPr>
           <a:xfrm>
-            <a:off x="813816" y="978408"/>
-            <a:ext cx="3721608" cy="1106424"/>
-          </a:xfrm>
-        </p:spPr>
-        <p:txBody>
-          <a:bodyPr vert="horz" lIns="91440" tIns="45720" rIns="91440" bIns="45720" rtlCol="0" anchor="ctr">
-            <a:normAutofit/>
+            <a:off x="786384" y="3154680"/>
+            <a:ext cx="1920240" cy="841248"/>
+          </a:xfrm>
+          <a:prstGeom prst="roundRect">
+            <a:avLst>
+              <a:gd name="adj" fmla="val 12000"/>
+            </a:avLst>
+          </a:prstGeom>
+          <a:solidFill>
+            <a:srgbClr val="F3F5F7"/>
+          </a:solidFill>
+          <a:ln w="12700">
+            <a:solidFill>
+              <a:srgbClr val="C9D1DA"/>
+            </a:solidFill>
+          </a:ln>
+        </p:spPr>
+        <p:txBody>
+          <a:bodyPr wrap="square" lIns="45720" tIns="45720" rIns="45720" bIns="45720" anchor="ctr">
+            <a:noAutofit/>
           </a:bodyPr>
           <a:lstStyle/>
           <a:p>
-            <a:r>
-              <a:rPr lang="en-US" sz="2800" kern="1200">
-                <a:solidFill>
-                  <a:schemeClr val="tx1"/>
-                </a:solidFill>
-                <a:latin typeface="+mj-lt"/>
-                <a:ea typeface="+mj-ea"/>
-                <a:cs typeface="+mj-cs"/>
+            <a:pPr algn="ctr"/>
+            <a:r>
+              <a:rPr lang="en-US" sz="1600" b="1" dirty="0">
+                <a:solidFill>
+                  <a:srgbClr val="22313F"/>
+                </a:solidFill>
+                <a:latin typeface="Aptos"/>
+                <a:ea typeface="Aptos"/>
+                <a:cs typeface="Aptos"/>
               </a:rPr>
-              <a:t>Waffle bot plates</a:t>
-            </a:r>
-          </a:p>
-        </p:txBody>
-      </p:sp>
-      <p:sp>
-        <p:nvSpPr>
-          <p:cNvPr id="29" name="Rectangle 28">
-            <a:extLst>
-              <a:ext uri="{FF2B5EF4-FFF2-40B4-BE49-F238E27FC236}">
-                <a16:creationId xmlns:a16="http://schemas.microsoft.com/office/drawing/2014/main" id="{2387511B-F6E1-4929-AC90-94FB8B6B0F41}"/>
-              </a:ext>
-              <a:ext uri="{C183D7F6-B498-43B3-948B-1728B52AA6E4}">
-                <adec:decorative xmlns:adec="http://schemas.microsoft.com/office/drawing/2017/decorative" val="1"/>
-              </a:ext>
-            </a:extLst>
-          </p:cNvPr>
-          <p:cNvSpPr>
-            <a:spLocks noGrp="1" noRot="1" noChangeAspect="1" noMove="1" noResize="1" noEditPoints="1" noAdjustHandles="1" noChangeArrowheads="1" noChangeShapeType="1" noTextEdit="1"/>
-          </p:cNvSpPr>
-          <p:nvPr>
-            <p:extLst>
-              <p:ext uri="{386F3935-93C4-4BCD-93E2-E3B085C9AB24}">
-                <p16:designElem xmlns:p16="http://schemas.microsoft.com/office/powerpoint/2015/main" val="1"/>
-              </p:ext>
-            </p:extLst>
-          </p:nvPr>
+              <a:t>Camera</a:t>
+            </a:r>
+          </a:p>
+          <a:p>
+            <a:pPr algn="ctr"/>
+            <a:r>
+              <a:rPr lang="en-US" sz="1200" b="0" dirty="0">
+                <a:solidFill>
+                  <a:srgbClr val="5B6773"/>
+                </a:solidFill>
+                <a:latin typeface="Aptos"/>
+                <a:ea typeface="Aptos"/>
+                <a:cs typeface="Aptos"/>
+              </a:rPr>
+              <a:t>Pi Camera Module 3</a:t>
+            </a:r>
+          </a:p>
+        </p:txBody>
+      </p:sp>
+      <p:sp>
+        <p:nvSpPr>
+          <p:cNvPr id="8" name="Sign detector"/>
+          <p:cNvSpPr/>
+          <p:nvPr/>
         </p:nvSpPr>
         <p:spPr>
           <a:xfrm>
-            <a:off x="317645" y="1181536"/>
-            <a:ext cx="128016" cy="704088"/>
+            <a:off x="3776472" y="3154680"/>
+            <a:ext cx="1920240" cy="841248"/>
+          </a:xfrm>
+          <a:prstGeom prst="roundRect">
+            <a:avLst>
+              <a:gd name="adj" fmla="val 12000"/>
+            </a:avLst>
+          </a:prstGeom>
+          <a:solidFill>
+            <a:srgbClr val="F3F5F7"/>
+          </a:solidFill>
+          <a:ln w="12700">
+            <a:solidFill>
+              <a:srgbClr val="C9D1DA"/>
+            </a:solidFill>
+          </a:ln>
+        </p:spPr>
+        <p:txBody>
+          <a:bodyPr wrap="square" lIns="45720" tIns="45720" rIns="45720" bIns="45720" anchor="ctr">
+            <a:noAutofit/>
+          </a:bodyPr>
+          <a:lstStyle/>
+          <a:p>
+            <a:pPr algn="ctr"/>
+            <a:r>
+              <a:rPr lang="en-US" sz="1600" b="1" dirty="0">
+                <a:solidFill>
+                  <a:srgbClr val="22313F"/>
+                </a:solidFill>
+                <a:latin typeface="Aptos"/>
+                <a:ea typeface="Aptos"/>
+                <a:cs typeface="Aptos"/>
+              </a:rPr>
+              <a:t>Sign detector</a:t>
+            </a:r>
+          </a:p>
+          <a:p>
+            <a:pPr algn="ctr"/>
+            <a:r>
+              <a:rPr lang="en-US" sz="1200" b="0" dirty="0">
+                <a:solidFill>
+                  <a:srgbClr val="5B6773"/>
+                </a:solidFill>
+                <a:latin typeface="Aptos"/>
+                <a:ea typeface="Aptos"/>
+                <a:cs typeface="Aptos"/>
+              </a:rPr>
+              <a:t>Vision model</a:t>
+            </a:r>
+          </a:p>
+        </p:txBody>
+      </p:sp>
+      <p:sp>
+        <p:nvSpPr>
+          <p:cNvPr id="9" name="Behavior"/>
+          <p:cNvSpPr/>
+          <p:nvPr/>
+        </p:nvSpPr>
+        <p:spPr>
+          <a:xfrm>
+            <a:off x="6766560" y="3154680"/>
+            <a:ext cx="1920240" cy="841248"/>
+          </a:xfrm>
+          <a:prstGeom prst="roundRect">
+            <a:avLst>
+              <a:gd name="adj" fmla="val 12000"/>
+            </a:avLst>
+          </a:prstGeom>
+          <a:solidFill>
+            <a:srgbClr val="30669D"/>
+          </a:solidFill>
+          <a:ln w="12700">
+            <a:solidFill>
+              <a:srgbClr val="30669D"/>
+            </a:solidFill>
+          </a:ln>
+        </p:spPr>
+        <p:txBody>
+          <a:bodyPr wrap="square" lIns="45720" tIns="45720" rIns="45720" bIns="45720" anchor="ctr">
+            <a:noAutofit/>
+          </a:bodyPr>
+          <a:lstStyle/>
+          <a:p>
+            <a:pPr algn="ctr"/>
+            <a:r>
+              <a:rPr lang="en-US" sz="1600" b="1" dirty="0">
+                <a:solidFill>
+                  <a:srgbClr val="FFFFFF"/>
+                </a:solidFill>
+                <a:latin typeface="Aptos"/>
+                <a:ea typeface="Aptos"/>
+                <a:cs typeface="Aptos"/>
+              </a:rPr>
+              <a:t>Behavior</a:t>
+            </a:r>
+          </a:p>
+          <a:p>
+            <a:pPr algn="ctr"/>
+            <a:r>
+              <a:rPr lang="en-US" sz="1200" b="0" dirty="0">
+                <a:solidFill>
+                  <a:srgbClr val="DCE6F1"/>
+                </a:solidFill>
+                <a:latin typeface="Aptos"/>
+                <a:ea typeface="Aptos"/>
+                <a:cs typeface="Aptos"/>
+              </a:rPr>
+              <a:t>State machine</a:t>
+            </a:r>
+          </a:p>
+        </p:txBody>
+      </p:sp>
+      <p:sp>
+        <p:nvSpPr>
+          <p:cNvPr id="10" name="Motor driver"/>
+          <p:cNvSpPr/>
+          <p:nvPr/>
+        </p:nvSpPr>
+        <p:spPr>
+          <a:xfrm>
+            <a:off x="9756648" y="3154680"/>
+            <a:ext cx="1920240" cy="841248"/>
+          </a:xfrm>
+          <a:prstGeom prst="roundRect">
+            <a:avLst>
+              <a:gd name="adj" fmla="val 12000"/>
+            </a:avLst>
+          </a:prstGeom>
+          <a:solidFill>
+            <a:srgbClr val="F3F5F7"/>
+          </a:solidFill>
+          <a:ln w="12700">
+            <a:solidFill>
+              <a:srgbClr val="C9D1DA"/>
+            </a:solidFill>
+          </a:ln>
+        </p:spPr>
+        <p:txBody>
+          <a:bodyPr wrap="square" lIns="45720" tIns="45720" rIns="45720" bIns="45720" anchor="ctr">
+            <a:noAutofit/>
+          </a:bodyPr>
+          <a:lstStyle/>
+          <a:p>
+            <a:pPr algn="ctr"/>
+            <a:r>
+              <a:rPr lang="en-US" sz="1600" b="1" dirty="0">
+                <a:solidFill>
+                  <a:srgbClr val="22313F"/>
+                </a:solidFill>
+                <a:latin typeface="Aptos"/>
+                <a:ea typeface="Aptos"/>
+                <a:cs typeface="Aptos"/>
+              </a:rPr>
+              <a:t>Motor driver</a:t>
+            </a:r>
+          </a:p>
+          <a:p>
+            <a:pPr algn="ctr"/>
+            <a:r>
+              <a:rPr lang="en-US" sz="1200" b="0" dirty="0">
+                <a:solidFill>
+                  <a:srgbClr val="5B6773"/>
+                </a:solidFill>
+                <a:latin typeface="Aptos"/>
+                <a:ea typeface="Aptos"/>
+                <a:cs typeface="Aptos"/>
+              </a:rPr>
+              <a:t>Waveshare HAT (I2C)</a:t>
+            </a:r>
+          </a:p>
+        </p:txBody>
+      </p:sp>
+      <p:cxnSp>
+        <p:nvCxnSpPr>
+          <p:cNvPr id="11" name="Arrow /image_raw"/>
+          <p:cNvCxnSpPr/>
+          <p:nvPr/>
+        </p:nvCxnSpPr>
+        <p:spPr>
+          <a:xfrm>
+            <a:off x="2752344" y="3575304"/>
+            <a:ext cx="978408" cy="0"/>
+          </a:xfrm>
+          <a:prstGeom prst="straightConnector1">
+            <a:avLst/>
+          </a:prstGeom>
+          <a:ln w="19050">
+            <a:solidFill>
+              <a:srgbClr val="5B6773"/>
+            </a:solidFill>
+            <a:tailEnd type="triangle" w="med" len="med"/>
+          </a:ln>
+        </p:spPr>
+      </p:cxnSp>
+      <p:sp>
+        <p:nvSpPr>
+          <p:cNvPr id="12" name="Topic /image_raw"/>
+          <p:cNvSpPr txBox="1"/>
+          <p:nvPr/>
+        </p:nvSpPr>
+        <p:spPr>
+          <a:xfrm>
+            <a:off x="2752344" y="3191256"/>
+            <a:ext cx="978408" cy="274320"/>
           </a:xfrm>
           <a:prstGeom prst="rect">
             <a:avLst/>
           </a:prstGeom>
-          <a:solidFill>
-            <a:schemeClr val="accent2"/>
-          </a:solidFill>
-          <a:ln>
-            <a:noFill/>
-          </a:ln>
-        </p:spPr>
-        <p:style>
-          <a:lnRef idx="2">
-            <a:schemeClr val="accent1">
-              <a:shade val="50000"/>
-            </a:schemeClr>
-          </a:lnRef>
-          <a:fillRef idx="1">
-            <a:schemeClr val="accent1"/>
-          </a:fillRef>
-          <a:effectRef idx="0">
-            <a:schemeClr val="accent1"/>
-          </a:effectRef>
-          <a:fontRef idx="minor">
-            <a:schemeClr val="lt1"/>
-          </a:fontRef>
-        </p:style>
-        <p:txBody>
-          <a:bodyPr rtlCol="0" anchor="ctr"/>
-          <a:lstStyle/>
-          <a:p>
-            <a:pPr marL="0" marR="0" lvl="0" indent="0" algn="ctr" defTabSz="914400" rtl="0" eaLnBrk="1" fontAlgn="auto" latinLnBrk="0" hangingPunct="1">
-              <a:lnSpc>
-                <a:spcPct val="100000"/>
-              </a:lnSpc>
+          <a:noFill/>
+        </p:spPr>
+        <p:txBody>
+          <a:bodyPr wrap="square" lIns="0" tIns="0" rIns="0" bIns="0" anchor="ctr">
+            <a:noAutofit/>
+          </a:bodyPr>
+          <a:lstStyle/>
+          <a:p>
+            <a:pPr marL="0" indent="0" algn="ctr">
               <a:spcBef>
                 <a:spcPts val="0"/>
               </a:spcBef>
-              <a:spcAft>
-                <a:spcPts val="0"/>
-              </a:spcAft>
-              <a:buClrTx/>
-              <a:buSzTx/>
-              <a:buFontTx/>
-              <a:buNone/>
-              <a:tabLst/>
-              <a:defRPr/>
+              <a:buNone/>
             </a:pPr>
-            <a:endParaRPr kumimoji="0" lang="en-US" sz="1800" b="0" i="0" u="none" strike="noStrike" kern="1200" cap="none" spc="0" normalizeH="0" baseline="0" noProof="0">
-              <a:ln>
-                <a:noFill/>
-              </a:ln>
-              <a:solidFill>
-                <a:prstClr val="white"/>
-              </a:solidFill>
-              <a:effectLst/>
-              <a:uLnTx/>
-              <a:uFillTx/>
-              <a:latin typeface="Calibri" panose="020F0502020204030204"/>
-              <a:ea typeface="+mn-ea"/>
-              <a:cs typeface="+mn-cs"/>
-            </a:endParaRPr>
-          </a:p>
-        </p:txBody>
-      </p:sp>
-      <p:sp>
-        <p:nvSpPr>
-          <p:cNvPr id="31" name="Rectangle 30">
-            <a:extLst>
-              <a:ext uri="{FF2B5EF4-FFF2-40B4-BE49-F238E27FC236}">
-                <a16:creationId xmlns:a16="http://schemas.microsoft.com/office/drawing/2014/main" id="{AA58F78C-27AB-465F-AA33-15E08AF267F9}"/>
-              </a:ext>
-              <a:ext uri="{C183D7F6-B498-43B3-948B-1728B52AA6E4}">
-                <adec:decorative xmlns:adec="http://schemas.microsoft.com/office/drawing/2017/decorative" val="1"/>
-              </a:ext>
-            </a:extLst>
-          </p:cNvPr>
-          <p:cNvSpPr>
-            <a:spLocks noGrp="1" noRot="1" noChangeAspect="1" noMove="1" noResize="1" noEditPoints="1" noAdjustHandles="1" noChangeArrowheads="1" noChangeShapeType="1" noTextEdit="1"/>
-          </p:cNvSpPr>
-          <p:nvPr>
-            <p:extLst>
-              <p:ext uri="{386F3935-93C4-4BCD-93E2-E3B085C9AB24}">
-                <p16:designElem xmlns:p16="http://schemas.microsoft.com/office/powerpoint/2015/main" val="1"/>
-              </p:ext>
-            </p:extLst>
-          </p:nvPr>
-        </p:nvSpPr>
+            <a:r>
+              <a:rPr lang="en-US" sz="1100" b="0" dirty="0">
+                <a:solidFill>
+                  <a:srgbClr val="5B6773"/>
+                </a:solidFill>
+                <a:latin typeface="Courier New"/>
+                <a:cs typeface="Courier New"/>
+              </a:rPr>
+              <a:t>/image_raw</a:t>
+            </a:r>
+          </a:p>
+        </p:txBody>
+      </p:sp>
+      <p:cxnSp>
+        <p:nvCxnSpPr>
+          <p:cNvPr id="13" name="Arrow /signs"/>
+          <p:cNvCxnSpPr/>
+          <p:nvPr/>
+        </p:nvCxnSpPr>
         <p:spPr>
           <a:xfrm>
-            <a:off x="843560" y="2185416"/>
-            <a:ext cx="3683187" cy="9144"/>
+            <a:off x="5742432" y="3575304"/>
+            <a:ext cx="978408" cy="0"/>
+          </a:xfrm>
+          <a:prstGeom prst="straightConnector1">
+            <a:avLst/>
+          </a:prstGeom>
+          <a:ln w="19050">
+            <a:solidFill>
+              <a:srgbClr val="5B6773"/>
+            </a:solidFill>
+            <a:tailEnd type="triangle" w="med" len="med"/>
+          </a:ln>
+        </p:spPr>
+      </p:cxnSp>
+      <p:sp>
+        <p:nvSpPr>
+          <p:cNvPr id="14" name="Topic /signs"/>
+          <p:cNvSpPr txBox="1"/>
+          <p:nvPr/>
+        </p:nvSpPr>
+        <p:spPr>
+          <a:xfrm>
+            <a:off x="5742432" y="3191256"/>
+            <a:ext cx="978408" cy="274320"/>
           </a:xfrm>
           <a:prstGeom prst="rect">
             <a:avLst/>
           </a:prstGeom>
-          <a:solidFill>
-            <a:srgbClr val="D5D5D5"/>
-          </a:solidFill>
-          <a:ln w="3175">
-            <a:noFill/>
-          </a:ln>
-          <a:effectLst/>
-        </p:spPr>
-        <p:style>
-          <a:lnRef idx="2">
-            <a:schemeClr val="accent1">
-              <a:shade val="50000"/>
-            </a:schemeClr>
-          </a:lnRef>
-          <a:fillRef idx="1">
-            <a:schemeClr val="accent1"/>
-          </a:fillRef>
-          <a:effectRef idx="0">
-            <a:schemeClr val="accent1"/>
-          </a:effectRef>
-          <a:fontRef idx="minor">
-            <a:schemeClr val="lt1"/>
-          </a:fontRef>
-        </p:style>
-        <p:txBody>
-          <a:bodyPr rtlCol="0" anchor="ctr"/>
-          <a:lstStyle/>
-          <a:p>
-            <a:pPr marL="0" marR="0" lvl="0" indent="0" algn="ctr" defTabSz="914400" rtl="0" eaLnBrk="1" fontAlgn="auto" latinLnBrk="0" hangingPunct="1">
-              <a:lnSpc>
-                <a:spcPct val="100000"/>
-              </a:lnSpc>
+          <a:noFill/>
+        </p:spPr>
+        <p:txBody>
+          <a:bodyPr wrap="square" lIns="0" tIns="0" rIns="0" bIns="0" anchor="ctr">
+            <a:noAutofit/>
+          </a:bodyPr>
+          <a:lstStyle/>
+          <a:p>
+            <a:pPr marL="0" indent="0" algn="ctr">
               <a:spcBef>
                 <a:spcPts val="0"/>
               </a:spcBef>
-              <a:spcAft>
-                <a:spcPts val="0"/>
-              </a:spcAft>
-              <a:buClrTx/>
-              <a:buSzTx/>
-              <a:buFontTx/>
-              <a:buNone/>
-              <a:tabLst/>
-              <a:defRPr/>
+              <a:buNone/>
             </a:pPr>
-            <a:endParaRPr kumimoji="0" lang="en-US" sz="1800" b="0" i="0" u="none" strike="noStrike" kern="1200" cap="none" spc="0" normalizeH="0" baseline="0" noProof="0">
-              <a:ln>
-                <a:noFill/>
-              </a:ln>
-              <a:solidFill>
-                <a:prstClr val="white"/>
-              </a:solidFill>
-              <a:effectLst/>
-              <a:uLnTx/>
-              <a:uFillTx/>
-              <a:latin typeface="Calibri" panose="020F0502020204030204"/>
-              <a:ea typeface="+mn-ea"/>
-              <a:cs typeface="+mn-cs"/>
-            </a:endParaRPr>
-          </a:p>
-        </p:txBody>
-      </p:sp>
-      <p:sp>
-        <p:nvSpPr>
-          <p:cNvPr id="12" name="TextBox 11">
-            <a:extLst>
-              <a:ext uri="{FF2B5EF4-FFF2-40B4-BE49-F238E27FC236}">
-                <a16:creationId xmlns:a16="http://schemas.microsoft.com/office/drawing/2014/main" id="{ABAE7B79-4E78-B0C2-2F1C-78B1C7B893A1}"/>
-              </a:ext>
-            </a:extLst>
-          </p:cNvPr>
+            <a:r>
+              <a:rPr lang="en-US" sz="1100" b="0" dirty="0">
+                <a:solidFill>
+                  <a:srgbClr val="5B6773"/>
+                </a:solidFill>
+                <a:latin typeface="Courier New"/>
+                <a:cs typeface="Courier New"/>
+              </a:rPr>
+              <a:t>/signs</a:t>
+            </a:r>
+          </a:p>
+        </p:txBody>
+      </p:sp>
+      <p:cxnSp>
+        <p:nvCxnSpPr>
+          <p:cNvPr id="15" name="Arrow /cmd_vel"/>
+          <p:cNvCxnSpPr/>
+          <p:nvPr/>
+        </p:nvCxnSpPr>
+        <p:spPr>
+          <a:xfrm>
+            <a:off x="8732520" y="3575304"/>
+            <a:ext cx="978408" cy="0"/>
+          </a:xfrm>
+          <a:prstGeom prst="straightConnector1">
+            <a:avLst/>
+          </a:prstGeom>
+          <a:ln w="19050">
+            <a:solidFill>
+              <a:srgbClr val="5B6773"/>
+            </a:solidFill>
+            <a:tailEnd type="triangle" w="med" len="med"/>
+          </a:ln>
+        </p:spPr>
+      </p:cxnSp>
+      <p:sp>
+        <p:nvSpPr>
+          <p:cNvPr id="16" name="Topic /cmd_vel"/>
           <p:cNvSpPr txBox="1"/>
           <p:nvPr/>
         </p:nvSpPr>
         <p:spPr>
           <a:xfrm>
-            <a:off x="813816" y="2368296"/>
-            <a:ext cx="3721608" cy="3502152"/>
+            <a:off x="8732520" y="3191256"/>
+            <a:ext cx="978408" cy="274320"/>
           </a:xfrm>
           <a:prstGeom prst="rect">
             <a:avLst/>
           </a:prstGeom>
-        </p:spPr>
-        <p:txBody>
-          <a:bodyPr vert="horz" lIns="91440" tIns="45720" rIns="91440" bIns="45720" rtlCol="0">
-            <a:normAutofit/>
+          <a:noFill/>
+        </p:spPr>
+        <p:txBody>
+          <a:bodyPr wrap="square" lIns="0" tIns="0" rIns="0" bIns="0" anchor="ctr">
+            <a:noAutofit/>
           </a:bodyPr>
           <a:lstStyle/>
           <a:p>
-            <a:pPr>
-              <a:lnSpc>
-                <a:spcPct val="90000"/>
-              </a:lnSpc>
-              <a:spcAft>
-                <a:spcPts val="600"/>
-              </a:spcAft>
+            <a:pPr marL="0" indent="0" algn="ctr">
+              <a:spcBef>
+                <a:spcPts val="0"/>
+              </a:spcBef>
+              <a:buNone/>
             </a:pPr>
             <a:r>
-              <a:rPr lang="en-US" sz="1700" dirty="0"/>
-              <a:t>I found some simplified Waffle plates on printables.com</a:t>
-            </a:r>
-          </a:p>
-          <a:p>
-            <a:pPr marL="285750" indent="-228600">
-              <a:lnSpc>
-                <a:spcPct val="90000"/>
-              </a:lnSpc>
-              <a:spcAft>
-                <a:spcPts val="600"/>
-              </a:spcAft>
-              <a:buFont typeface="Arial" panose="020B0604020202020204" pitchFamily="34" charset="0"/>
-              <a:buChar char="•"/>
-            </a:pPr>
-            <a:r>
-              <a:rPr lang="en-US" sz="1700" dirty="0"/>
-              <a:t>One with no holes</a:t>
-            </a:r>
-          </a:p>
-          <a:p>
-            <a:pPr marL="285750" indent="-228600">
-              <a:lnSpc>
-                <a:spcPct val="90000"/>
-              </a:lnSpc>
-              <a:spcAft>
-                <a:spcPts val="600"/>
-              </a:spcAft>
-              <a:buFont typeface="Arial" panose="020B0604020202020204" pitchFamily="34" charset="0"/>
-              <a:buChar char="•"/>
-            </a:pPr>
-            <a:r>
-              <a:rPr lang="en-US" sz="1700" dirty="0"/>
-              <a:t>One being a simple plate</a:t>
-            </a:r>
-          </a:p>
-          <a:p>
-            <a:pPr marL="285750" indent="-228600">
-              <a:lnSpc>
-                <a:spcPct val="90000"/>
-              </a:lnSpc>
-              <a:spcAft>
-                <a:spcPts val="600"/>
-              </a:spcAft>
-              <a:buFont typeface="Arial" panose="020B0604020202020204" pitchFamily="34" charset="0"/>
-              <a:buChar char="•"/>
-            </a:pPr>
-            <a:r>
-              <a:rPr lang="en-US" sz="1700" dirty="0"/>
-              <a:t>Two being different doubles</a:t>
-            </a:r>
-          </a:p>
-        </p:txBody>
-      </p:sp>
-      <p:pic>
-        <p:nvPicPr>
-          <p:cNvPr id="5" name="Content Placeholder 4">
-            <a:extLst>
-              <a:ext uri="{FF2B5EF4-FFF2-40B4-BE49-F238E27FC236}">
-                <a16:creationId xmlns:a16="http://schemas.microsoft.com/office/drawing/2014/main" id="{9A22B260-71E4-61AF-270D-7F0B9A2AC581}"/>
-              </a:ext>
-            </a:extLst>
-          </p:cNvPr>
-          <p:cNvPicPr>
-            <a:picLocks noGrp="1" noChangeAspect="1"/>
-          </p:cNvPicPr>
-          <p:nvPr>
-            <p:ph idx="1"/>
-          </p:nvPr>
-        </p:nvPicPr>
-        <p:blipFill>
-          <a:blip r:embed="rId2"/>
-          <a:srcRect l="17124" r="20167" b="-2"/>
-          <a:stretch>
-            <a:fillRect/>
-          </a:stretch>
-        </p:blipFill>
+              <a:rPr lang="en-US" sz="1100" b="0" dirty="0">
+                <a:solidFill>
+                  <a:srgbClr val="5B6773"/>
+                </a:solidFill>
+                <a:latin typeface="Courier New"/>
+                <a:cs typeface="Courier New"/>
+              </a:rPr>
+              <a:t>/cmd_vel</a:t>
+            </a:r>
+          </a:p>
+        </p:txBody>
+      </p:sp>
+      <p:sp>
+        <p:nvSpPr>
+          <p:cNvPr id="17" name="IMU"/>
+          <p:cNvSpPr/>
+          <p:nvPr/>
+        </p:nvSpPr>
         <p:spPr>
           <a:xfrm>
-            <a:off x="5171031" y="10"/>
-            <a:ext cx="3144714" cy="3209534"/>
+            <a:off x="3776472" y="5120640"/>
+            <a:ext cx="1920240" cy="841248"/>
+          </a:xfrm>
+          <a:prstGeom prst="roundRect">
+            <a:avLst>
+              <a:gd name="adj" fmla="val 12000"/>
+            </a:avLst>
+          </a:prstGeom>
+          <a:solidFill>
+            <a:srgbClr val="F3F5F7"/>
+          </a:solidFill>
+          <a:ln w="12700">
+            <a:solidFill>
+              <a:srgbClr val="C9D1DA"/>
+            </a:solidFill>
+          </a:ln>
+        </p:spPr>
+        <p:txBody>
+          <a:bodyPr wrap="square" lIns="45720" tIns="45720" rIns="45720" bIns="45720" anchor="ctr">
+            <a:noAutofit/>
+          </a:bodyPr>
+          <a:lstStyle/>
+          <a:p>
+            <a:pPr algn="ctr"/>
+            <a:r>
+              <a:rPr lang="en-US" sz="1600" b="1" dirty="0">
+                <a:solidFill>
+                  <a:srgbClr val="22313F"/>
+                </a:solidFill>
+                <a:latin typeface="Aptos"/>
+                <a:ea typeface="Aptos"/>
+                <a:cs typeface="Aptos"/>
+              </a:rPr>
+              <a:t>IMU</a:t>
+            </a:r>
+          </a:p>
+          <a:p>
+            <a:pPr algn="ctr"/>
+            <a:r>
+              <a:rPr lang="en-US" sz="1200" b="0" dirty="0">
+                <a:solidFill>
+                  <a:srgbClr val="5B6773"/>
+                </a:solidFill>
+                <a:latin typeface="Aptos"/>
+                <a:ea typeface="Aptos"/>
+                <a:cs typeface="Aptos"/>
+              </a:rPr>
+              <a:t>IMU (I2C)</a:t>
+            </a:r>
+          </a:p>
+        </p:txBody>
+      </p:sp>
+      <p:sp>
+        <p:nvSpPr>
+          <p:cNvPr id="18" name="LCD"/>
+          <p:cNvSpPr/>
+          <p:nvPr/>
+        </p:nvSpPr>
+        <p:spPr>
+          <a:xfrm>
+            <a:off x="6766560" y="5120640"/>
+            <a:ext cx="1920240" cy="841248"/>
+          </a:xfrm>
+          <a:prstGeom prst="roundRect">
+            <a:avLst>
+              <a:gd name="adj" fmla="val 12000"/>
+            </a:avLst>
+          </a:prstGeom>
+          <a:solidFill>
+            <a:srgbClr val="F3F5F7"/>
+          </a:solidFill>
+          <a:ln w="12700">
+            <a:solidFill>
+              <a:srgbClr val="C9D1DA"/>
+            </a:solidFill>
+          </a:ln>
+        </p:spPr>
+        <p:txBody>
+          <a:bodyPr wrap="square" lIns="45720" tIns="45720" rIns="45720" bIns="45720" anchor="ctr">
+            <a:noAutofit/>
+          </a:bodyPr>
+          <a:lstStyle/>
+          <a:p>
+            <a:pPr algn="ctr"/>
+            <a:r>
+              <a:rPr lang="en-US" sz="1600" b="1" dirty="0">
+                <a:solidFill>
+                  <a:srgbClr val="22313F"/>
+                </a:solidFill>
+                <a:latin typeface="Aptos"/>
+                <a:ea typeface="Aptos"/>
+                <a:cs typeface="Aptos"/>
+              </a:rPr>
+              <a:t>LCD</a:t>
+            </a:r>
+          </a:p>
+          <a:p>
+            <a:pPr algn="ctr"/>
+            <a:r>
+              <a:rPr lang="en-US" sz="1200" b="0" dirty="0">
+                <a:solidFill>
+                  <a:srgbClr val="5B6773"/>
+                </a:solidFill>
+                <a:latin typeface="Aptos"/>
+                <a:ea typeface="Aptos"/>
+                <a:cs typeface="Aptos"/>
+              </a:rPr>
+              <a:t>LCD display (I2C)</a:t>
+            </a:r>
+          </a:p>
+        </p:txBody>
+      </p:sp>
+      <p:sp>
+        <p:nvSpPr>
+          <p:cNvPr id="19" name="Teleop"/>
+          <p:cNvSpPr/>
+          <p:nvPr/>
+        </p:nvSpPr>
+        <p:spPr>
+          <a:xfrm>
+            <a:off x="9756648" y="5120640"/>
+            <a:ext cx="1920240" cy="841248"/>
+          </a:xfrm>
+          <a:prstGeom prst="roundRect">
+            <a:avLst>
+              <a:gd name="adj" fmla="val 12000"/>
+            </a:avLst>
+          </a:prstGeom>
+          <a:solidFill>
+            <a:srgbClr val="F3F5F7"/>
+          </a:solidFill>
+          <a:ln w="12700">
+            <a:solidFill>
+              <a:srgbClr val="C9D1DA"/>
+            </a:solidFill>
+          </a:ln>
+        </p:spPr>
+        <p:txBody>
+          <a:bodyPr wrap="square" lIns="45720" tIns="45720" rIns="45720" bIns="45720" anchor="ctr">
+            <a:noAutofit/>
+          </a:bodyPr>
+          <a:lstStyle/>
+          <a:p>
+            <a:pPr algn="ctr"/>
+            <a:r>
+              <a:rPr lang="en-US" sz="1600" b="1" dirty="0">
+                <a:solidFill>
+                  <a:srgbClr val="22313F"/>
+                </a:solidFill>
+                <a:latin typeface="Aptos"/>
+                <a:ea typeface="Aptos"/>
+                <a:cs typeface="Aptos"/>
+              </a:rPr>
+              <a:t>Teleop</a:t>
+            </a:r>
+          </a:p>
+          <a:p>
+            <a:pPr algn="ctr"/>
+            <a:r>
+              <a:rPr lang="en-US" sz="1200" b="0" dirty="0">
+                <a:solidFill>
+                  <a:srgbClr val="5B6773"/>
+                </a:solidFill>
+                <a:latin typeface="Aptos"/>
+                <a:ea typeface="Aptos"/>
+                <a:cs typeface="Aptos"/>
+              </a:rPr>
+              <a:t>Laptop keyboard</a:t>
+            </a:r>
+          </a:p>
+        </p:txBody>
+      </p:sp>
+      <p:cxnSp>
+        <p:nvCxnSpPr>
+          <p:cNvPr id="20" name="Arrow /imu"/>
+          <p:cNvCxnSpPr/>
+          <p:nvPr/>
+        </p:nvCxnSpPr>
+        <p:spPr>
+          <a:xfrm flipV="1">
+            <a:off x="5468112" y="4041648"/>
+            <a:ext cx="1618488" cy="1033272"/>
+          </a:xfrm>
+          <a:prstGeom prst="straightConnector1">
+            <a:avLst/>
+          </a:prstGeom>
+          <a:ln w="19050">
+            <a:solidFill>
+              <a:srgbClr val="5B6773"/>
+            </a:solidFill>
+            <a:tailEnd type="triangle" w="med" len="med"/>
+          </a:ln>
+        </p:spPr>
+      </p:cxnSp>
+      <p:sp>
+        <p:nvSpPr>
+          <p:cNvPr id="21" name="Topic /imu"/>
+          <p:cNvSpPr txBox="1"/>
+          <p:nvPr/>
+        </p:nvSpPr>
+        <p:spPr>
+          <a:xfrm>
+            <a:off x="6551676" y="4512564"/>
+            <a:ext cx="640080" cy="274320"/>
           </a:xfrm>
           <a:prstGeom prst="rect">
             <a:avLst/>
           </a:prstGeom>
-        </p:spPr>
-      </p:pic>
-      <p:pic>
-        <p:nvPicPr>
-          <p:cNvPr id="7" name="Picture 6">
-            <a:extLst>
-              <a:ext uri="{FF2B5EF4-FFF2-40B4-BE49-F238E27FC236}">
-                <a16:creationId xmlns:a16="http://schemas.microsoft.com/office/drawing/2014/main" id="{F24AECCB-24C6-4B83-4AB9-593BDB264B59}"/>
-              </a:ext>
-            </a:extLst>
-          </p:cNvPr>
-          <p:cNvPicPr>
-            <a:picLocks noChangeAspect="1"/>
-          </p:cNvPicPr>
+          <a:noFill/>
+        </p:spPr>
+        <p:txBody>
+          <a:bodyPr wrap="square" lIns="0" tIns="0" rIns="0" bIns="0" anchor="ctr">
+            <a:noAutofit/>
+          </a:bodyPr>
+          <a:lstStyle/>
+          <a:p>
+            <a:pPr marL="0" indent="0" algn="l">
+              <a:spcBef>
+                <a:spcPts val="0"/>
+              </a:spcBef>
+              <a:buNone/>
+            </a:pPr>
+            <a:r>
+              <a:rPr lang="en-US" sz="1100" b="0" dirty="0">
+                <a:solidFill>
+                  <a:srgbClr val="5B6773"/>
+                </a:solidFill>
+                <a:latin typeface="Courier New"/>
+                <a:cs typeface="Courier New"/>
+              </a:rPr>
+              <a:t>/imu</a:t>
+            </a:r>
+          </a:p>
+        </p:txBody>
+      </p:sp>
+      <p:cxnSp>
+        <p:nvCxnSpPr>
+          <p:cNvPr id="22" name="Arrow /status"/>
+          <p:cNvCxnSpPr/>
           <p:nvPr/>
-        </p:nvPicPr>
-        <p:blipFill>
-          <a:blip r:embed="rId3"/>
-          <a:srcRect l="15725" r="12036"/>
-          <a:stretch>
-            <a:fillRect/>
-          </a:stretch>
-        </p:blipFill>
+        </p:nvCxnSpPr>
         <p:spPr>
           <a:xfrm>
-            <a:off x="5171033" y="3310128"/>
-            <a:ext cx="3144712" cy="3547872"/>
+            <a:off x="7955280" y="4041648"/>
+            <a:ext cx="0" cy="1033272"/>
+          </a:xfrm>
+          <a:prstGeom prst="straightConnector1">
+            <a:avLst/>
+          </a:prstGeom>
+          <a:ln w="19050">
+            <a:solidFill>
+              <a:srgbClr val="5B6773"/>
+            </a:solidFill>
+            <a:tailEnd type="triangle" w="med" len="med"/>
+          </a:ln>
+        </p:spPr>
+      </p:cxnSp>
+      <p:sp>
+        <p:nvSpPr>
+          <p:cNvPr id="23" name="Topic /status"/>
+          <p:cNvSpPr txBox="1"/>
+          <p:nvPr/>
+        </p:nvSpPr>
+        <p:spPr>
+          <a:xfrm>
+            <a:off x="8065008" y="4421124"/>
+            <a:ext cx="914400" cy="274320"/>
           </a:xfrm>
           <a:prstGeom prst="rect">
             <a:avLst/>
           </a:prstGeom>
-        </p:spPr>
-      </p:pic>
-      <p:pic>
-        <p:nvPicPr>
-          <p:cNvPr id="11" name="Picture 10">
-            <a:extLst>
-              <a:ext uri="{FF2B5EF4-FFF2-40B4-BE49-F238E27FC236}">
-                <a16:creationId xmlns:a16="http://schemas.microsoft.com/office/drawing/2014/main" id="{E5244B0E-E9C2-D93F-4555-E1ADC15B5386}"/>
-              </a:ext>
-            </a:extLst>
-          </p:cNvPr>
-          <p:cNvPicPr>
-            <a:picLocks noChangeAspect="1"/>
-          </p:cNvPicPr>
+          <a:noFill/>
+        </p:spPr>
+        <p:txBody>
+          <a:bodyPr wrap="square" lIns="0" tIns="0" rIns="0" bIns="0" anchor="ctr">
+            <a:noAutofit/>
+          </a:bodyPr>
+          <a:lstStyle/>
+          <a:p>
+            <a:pPr marL="0" indent="0" algn="l">
+              <a:spcBef>
+                <a:spcPts val="0"/>
+              </a:spcBef>
+              <a:buNone/>
+            </a:pPr>
+            <a:r>
+              <a:rPr lang="en-US" sz="1100" b="0" dirty="0">
+                <a:solidFill>
+                  <a:srgbClr val="5B6773"/>
+                </a:solidFill>
+                <a:latin typeface="Courier New"/>
+                <a:cs typeface="Courier New"/>
+              </a:rPr>
+              <a:t>/status</a:t>
+            </a:r>
+          </a:p>
+        </p:txBody>
+      </p:sp>
+      <p:cxnSp>
+        <p:nvCxnSpPr>
+          <p:cNvPr id="24" name="Arrow teleop"/>
+          <p:cNvCxnSpPr/>
           <p:nvPr/>
-        </p:nvPicPr>
-        <p:blipFill>
-          <a:blip r:embed="rId4"/>
-          <a:srcRect l="17005" r="8313" b="-3"/>
-          <a:stretch>
-            <a:fillRect/>
-          </a:stretch>
-        </p:blipFill>
+        </p:nvCxnSpPr>
+        <p:spPr>
+          <a:xfrm flipV="1">
+            <a:off x="10716768" y="4041648"/>
+            <a:ext cx="0" cy="1033272"/>
+          </a:xfrm>
+          <a:prstGeom prst="straightConnector1">
+            <a:avLst/>
+          </a:prstGeom>
+          <a:ln w="19050">
+            <a:solidFill>
+              <a:srgbClr val="5B6773"/>
+            </a:solidFill>
+            <a:tailEnd type="triangle" w="med" len="med"/>
+          </a:ln>
+        </p:spPr>
+      </p:cxnSp>
+      <p:sp>
+        <p:nvSpPr>
+          <p:cNvPr id="25" name="Topic /cmd_vel"/>
+          <p:cNvSpPr txBox="1"/>
+          <p:nvPr/>
+        </p:nvSpPr>
         <p:spPr>
           <a:xfrm>
-            <a:off x="8416348" y="10"/>
-            <a:ext cx="3775651" cy="4133078"/>
+            <a:off x="10826496" y="4265676"/>
+            <a:ext cx="914400" cy="274320"/>
           </a:xfrm>
           <a:prstGeom prst="rect">
             <a:avLst/>
           </a:prstGeom>
-        </p:spPr>
-      </p:pic>
-      <p:pic>
-        <p:nvPicPr>
-          <p:cNvPr id="9" name="Picture 8">
-            <a:extLst>
-              <a:ext uri="{FF2B5EF4-FFF2-40B4-BE49-F238E27FC236}">
-                <a16:creationId xmlns:a16="http://schemas.microsoft.com/office/drawing/2014/main" id="{C28A1D29-825A-D98C-E441-F5CBF4A1803C}"/>
-              </a:ext>
-            </a:extLst>
-          </p:cNvPr>
-          <p:cNvPicPr>
-            <a:picLocks noChangeAspect="1"/>
-          </p:cNvPicPr>
+          <a:noFill/>
+        </p:spPr>
+        <p:txBody>
+          <a:bodyPr wrap="square" lIns="0" tIns="0" rIns="0" bIns="0" anchor="ctr">
+            <a:noAutofit/>
+          </a:bodyPr>
+          <a:lstStyle/>
+          <a:p>
+            <a:pPr marL="0" indent="0" algn="l">
+              <a:spcBef>
+                <a:spcPts val="0"/>
+              </a:spcBef>
+              <a:buNone/>
+            </a:pPr>
+            <a:r>
+              <a:rPr lang="en-US" sz="1100" b="0" dirty="0">
+                <a:solidFill>
+                  <a:srgbClr val="5B6773"/>
+                </a:solidFill>
+                <a:latin typeface="Courier New"/>
+                <a:cs typeface="Courier New"/>
+              </a:rPr>
+              <a:t>/cmd_vel</a:t>
+            </a:r>
+          </a:p>
+        </p:txBody>
+      </p:sp>
+      <p:sp>
+        <p:nvSpPr>
+          <p:cNvPr id="26" name="Topic (manual)"/>
+          <p:cNvSpPr txBox="1"/>
           <p:nvPr/>
-        </p:nvPicPr>
-        <p:blipFill>
-          <a:blip r:embed="rId5"/>
-          <a:srcRect l="4765" r="1003" b="5"/>
-          <a:stretch>
-            <a:fillRect/>
-          </a:stretch>
-        </p:blipFill>
+        </p:nvSpPr>
         <p:spPr>
           <a:xfrm>
-            <a:off x="8416348" y="4233672"/>
-            <a:ext cx="3775652" cy="2624328"/>
+            <a:off x="10826496" y="4576572"/>
+            <a:ext cx="914400" cy="274320"/>
           </a:xfrm>
           <a:prstGeom prst="rect">
             <a:avLst/>
           </a:prstGeom>
-        </p:spPr>
-      </p:pic>
+          <a:noFill/>
+        </p:spPr>
+        <p:txBody>
+          <a:bodyPr wrap="square" lIns="0" tIns="0" rIns="0" bIns="0" anchor="ctr">
+            <a:noAutofit/>
+          </a:bodyPr>
+          <a:lstStyle/>
+          <a:p>
+            <a:pPr marL="0" indent="0" algn="l">
+              <a:spcBef>
+                <a:spcPts val="0"/>
+              </a:spcBef>
+              <a:buNone/>
+            </a:pPr>
+            <a:r>
+              <a:rPr lang="en-US" sz="1100" b="0" dirty="0">
+                <a:solidFill>
+                  <a:srgbClr val="5B6773"/>
+                </a:solidFill>
+                <a:latin typeface="Courier New"/>
+                <a:cs typeface="Courier New"/>
+              </a:rPr>
+              <a:t>(manual)</a:t>
+            </a:r>
+          </a:p>
+        </p:txBody>
+      </p:sp>
     </p:spTree>
-    <p:extLst>
-      <p:ext uri="{BB962C8B-B14F-4D97-AF65-F5344CB8AC3E}">
-        <p14:creationId xmlns:p14="http://schemas.microsoft.com/office/powerpoint/2010/main" val="1638007650"/>
-      </p:ext>
-    </p:extLst>
   </p:cSld>
   <p:clrMapOvr>
     <a:masterClrMapping/>

</xml_diff>

<commit_message>
Week 10 slide update
</commit_message>
<xml_diff>
--- a/Weekly Reports/slides/3-ethan-bishop.pptx
+++ b/Weekly Reports/slides/3-ethan-bishop.pptx
@@ -7,7 +7,7 @@
   <p:sldIdLst>
     <p:sldId id="261" r:id="rId2"/>
     <p:sldId id="263" r:id="rId3"/>
-    <p:sldId id="265" r:id="rId4"/>
+    <p:sldId id="264" r:id="rId9"/>
   </p:sldIdLst>
   <p:sldSz cx="12192000" cy="6858000"/>
   <p:notesSz cx="6858000" cy="9144000"/>
@@ -3400,7 +3400,7 @@
             <a:pPr lvl="1"/>
             <a:r>
               <a:rPr lang="en-US" dirty="0"/>
-              <a:t>Research on a possible ROS 2 implementation</a:t>
+              <a:t>Create a test program for the ROS 2 implementation</a:t>
             </a:r>
           </a:p>
           <a:p>
@@ -3413,14 +3413,21 @@
             <a:pPr lvl="1"/>
             <a:r>
               <a:rPr lang="en-US" dirty="0"/>
-              <a:t>Installed ROS 2 under WSL</a:t>
+              <a:t>Built a master test script for every sensor and the motor driver</a:t>
             </a:r>
           </a:p>
           <a:p>
             <a:pPr lvl="1"/>
             <a:r>
               <a:rPr lang="en-US" dirty="0"/>
-              <a:t>Drafted the ROS 2 node architecture</a:t>
+              <a:t>Ran the ROS 2 turtlesim tutorial under WSL</a:t>
+            </a:r>
+          </a:p>
+          <a:p>
+            <a:pPr lvl="1"/>
+            <a:r>
+              <a:rPr lang="en-US" dirty="0"/>
+              <a:t>Started the ROS 2 test program</a:t>
             </a:r>
           </a:p>
           <a:p>
@@ -3433,15 +3440,7 @@
             <a:pPr lvl="1"/>
             <a:r>
               <a:rPr lang="en-US" dirty="0"/>
-              <a:t>Create a test </a:t>
-            </a:r>
-            <a:r>
-              <a:rPr lang="en-US"/>
-              <a:t>program for </a:t>
-            </a:r>
-            <a:r>
-              <a:rPr lang="en-US" dirty="0"/>
-              <a:t>ROS 2 implementation</a:t>
+              <a:t>Write a first ROS 2 test node and run it on the CM5</a:t>
             </a:r>
           </a:p>
           <a:p>
@@ -3525,7 +3524,7 @@
                 <a:ea typeface="Aptos Display"/>
                 <a:cs typeface="Aptos Display"/>
               </a:rPr>
-              <a:t>ROS 2 could split our pipeline into eight nodes</a:t>
+              <a:t>One script now bench-tests every sensor and the motors</a:t>
             </a:r>
           </a:p>
         </p:txBody>
@@ -3567,14 +3566,14 @@
                 <a:ea typeface="Aptos"/>
                 <a:cs typeface="Aptos"/>
               </a:rPr>
-              <a:t>Preliminary node structure for the car; each node does one job</a:t>
-            </a:r>
-          </a:p>
-        </p:txBody>
-      </p:sp>
-      <p:sp>
-        <p:nvSpPr>
-          <p:cNvPr id="4" name="Nodes"/>
+              <a:t>test_all_sensors.py runs each device check in turn, then prints a PASS / FAIL / SKIP summary</a:t>
+            </a:r>
+          </a:p>
+        </p:txBody>
+      </p:sp>
+      <p:sp>
+        <p:nvSpPr>
+          <p:cNvPr id="4" name="Checks"/>
           <p:cNvSpPr txBox="1"/>
           <p:nvPr/>
         </p:nvSpPr>
@@ -3609,14 +3608,14 @@
                 <a:ea typeface="Aptos"/>
                 <a:cs typeface="Aptos"/>
               </a:rPr>
-              <a:t>Nodes</a:t>
-            </a:r>
-          </a:p>
-        </p:txBody>
-      </p:sp>
-      <p:sp>
-        <p:nvSpPr>
-          <p:cNvPr id="5" name="Node list"/>
+              <a:t>What it checks</a:t>
+            </a:r>
+          </a:p>
+        </p:txBody>
+      </p:sp>
+      <p:sp>
+        <p:nvSpPr>
+          <p:cNvPr id="5" name="Check list"/>
           <p:cNvSpPr txBox="1"/>
           <p:nvPr/>
         </p:nvSpPr>
@@ -3655,7 +3654,7 @@
                 <a:ea typeface="Aptos"/>
                 <a:cs typeface="Aptos"/>
               </a:rPr>
-              <a:t>Camera: </a:t>
+              <a:t>Line sensors: </a:t>
             </a:r>
             <a:r>
               <a:rPr lang="en-US" sz="1600" b="0" dirty="0">
@@ -3666,7 +3665,7 @@
                 <a:ea typeface="Aptos"/>
                 <a:cs typeface="Aptos"/>
               </a:rPr>
-              <a:t>streams video from the Pi Camera Module 3</a:t>
+              <a:t>both TCRT5000 outputs must change when a dark line passes under them (GPIO20, GPIO21)</a:t>
             </a:r>
           </a:p>
           <a:p>
@@ -3689,7 +3688,7 @@
                 <a:ea typeface="Aptos"/>
                 <a:cs typeface="Aptos"/>
               </a:rPr>
-              <a:t>Sign detector: </a:t>
+              <a:t>IMU: </a:t>
             </a:r>
             <a:r>
               <a:rPr lang="en-US" sz="1600" b="0" dirty="0">
@@ -3700,7 +3699,7 @@
                 <a:ea typeface="Aptos"/>
                 <a:cs typeface="Aptos"/>
               </a:rPr>
-              <a:t>runs the vision model and reports each sign’s type, confidence and position</a:t>
+              <a:t>finds the ICM-20948 on I2C, then runs still, motion and sample-rate checks</a:t>
             </a:r>
           </a:p>
           <a:p>
@@ -3723,7 +3722,7 @@
                 <a:ea typeface="Aptos"/>
                 <a:cs typeface="Aptos"/>
               </a:rPr>
-              <a:t>Line sensor: </a:t>
+              <a:t>Camera: </a:t>
             </a:r>
             <a:r>
               <a:rPr lang="en-US" sz="1600" b="0" dirty="0">
@@ -3734,7 +3733,7 @@
                 <a:ea typeface="Aptos"/>
                 <a:cs typeface="Aptos"/>
               </a:rPr>
-              <a:t>tracks the lane lines with TCRT5000 IR sensors</a:t>
+              <a:t>captures a Camera Module 3 frame and fails if it is almost black</a:t>
             </a:r>
           </a:p>
           <a:p>
@@ -3757,7 +3756,7 @@
                 <a:ea typeface="Aptos"/>
                 <a:cs typeface="Aptos"/>
               </a:rPr>
-              <a:t>IMU: </a:t>
+              <a:t>LCD: </a:t>
             </a:r>
             <a:r>
               <a:rPr lang="en-US" sz="1600" b="0" dirty="0">
@@ -3768,7 +3767,7 @@
                 <a:ea typeface="Aptos"/>
                 <a:cs typeface="Aptos"/>
               </a:rPr>
-              <a:t>reports turning and motion; detects if the car is stuck</a:t>
+              <a:t>writes text to the LCD1602 and cycles the RGB backlight for a visual check</a:t>
             </a:r>
           </a:p>
           <a:p>
@@ -3791,7 +3790,7 @@
                 <a:ea typeface="Aptos"/>
                 <a:cs typeface="Aptos"/>
               </a:rPr>
-              <a:t>Behavior: </a:t>
+              <a:t>Motors: </a:t>
             </a:r>
             <a:r>
               <a:rPr lang="en-US" sz="1600" b="0" dirty="0">
@@ -3802,7 +3801,95 @@
                 <a:ea typeface="Aptos"/>
                 <a:cs typeface="Aptos"/>
               </a:rPr>
-              <a:t>a state machine that turns signs, lane position and IMU data into driving decisions</a:t>
+              <a:t>spins each motor on the selected HAT (Cokoino, Waveshare or Adafruit) then stops them all</a:t>
+            </a:r>
+          </a:p>
+        </p:txBody>
+      </p:sp>
+      <p:sp>
+        <p:nvSpPr>
+          <p:cNvPr id="6" name="Why"/>
+          <p:cNvSpPr txBox="1"/>
+          <p:nvPr/>
+        </p:nvSpPr>
+        <p:spPr>
+          <a:xfrm>
+            <a:off x="7635240" y="1719072"/>
+            <a:ext cx="3794760" cy="384048"/>
+          </a:xfrm>
+          <a:prstGeom prst="rect">
+            <a:avLst/>
+          </a:prstGeom>
+          <a:noFill/>
+        </p:spPr>
+        <p:txBody>
+          <a:bodyPr wrap="square" lIns="0" tIns="0" rIns="0" bIns="0" anchor="t">
+            <a:noAutofit/>
+          </a:bodyPr>
+          <a:lstStyle/>
+          <a:p>
+            <a:pPr marL="0" indent="0" algn="l">
+              <a:spcBef>
+                <a:spcPts val="0"/>
+              </a:spcBef>
+              <a:buNone/>
+            </a:pPr>
+            <a:r>
+              <a:rPr lang="en-US" sz="1950" b="1" dirty="0">
+                <a:solidFill>
+                  <a:srgbClr val="30669D"/>
+                </a:solidFill>
+                <a:latin typeface="Aptos"/>
+                <a:ea typeface="Aptos"/>
+                <a:cs typeface="Aptos"/>
+              </a:rPr>
+              <a:t>Why one script</a:t>
+            </a:r>
+          </a:p>
+        </p:txBody>
+      </p:sp>
+      <p:sp>
+        <p:nvSpPr>
+          <p:cNvPr id="7" name="Why list"/>
+          <p:cNvSpPr txBox="1"/>
+          <p:nvPr/>
+        </p:nvSpPr>
+        <p:spPr>
+          <a:xfrm>
+            <a:off x="7635240" y="2240280"/>
+            <a:ext cx="3794760" cy="2103120"/>
+          </a:xfrm>
+          <a:prstGeom prst="rect">
+            <a:avLst/>
+          </a:prstGeom>
+          <a:noFill/>
+        </p:spPr>
+        <p:txBody>
+          <a:bodyPr wrap="square" lIns="0" tIns="0" rIns="0" bIns="0" anchor="t">
+            <a:noAutofit/>
+          </a:bodyPr>
+          <a:lstStyle/>
+          <a:p>
+            <a:pPr marL="228600" indent="-228600" algn="l">
+              <a:spcBef>
+                <a:spcPts val="0"/>
+              </a:spcBef>
+              <a:buClr>
+                <a:srgbClr val="30669D"/>
+              </a:buClr>
+              <a:buFont typeface="Arial"/>
+              <a:buChar char="•"/>
+            </a:pPr>
+            <a:r>
+              <a:rPr lang="en-US" sz="1600" b="0" dirty="0">
+                <a:solidFill>
+                  <a:srgbClr val="000000"/>
+                </a:solidFill>
+                <a:latin typeface="Aptos"/>
+                <a:ea typeface="Aptos"/>
+                <a:cs typeface="Aptos"/>
+              </a:rPr>
+              <a:t>A failed test never stops the others</a:t>
             </a:r>
           </a:p>
           <a:p>
@@ -3817,17 +3904,6 @@
               <a:buChar char="•"/>
             </a:pPr>
             <a:r>
-              <a:rPr lang="en-US" sz="1600" b="1" dirty="0">
-                <a:solidFill>
-                  <a:srgbClr val="000000"/>
-                </a:solidFill>
-                <a:latin typeface="Aptos"/>
-                <a:ea typeface="Aptos"/>
-                <a:cs typeface="Aptos"/>
-              </a:rPr>
-              <a:t>Motor driver: </a:t>
-            </a:r>
-            <a:r>
               <a:rPr lang="en-US" sz="1600" b="0" dirty="0">
                 <a:solidFill>
                   <a:srgbClr val="000000"/>
@@ -3836,7 +3912,7 @@
                 <a:ea typeface="Aptos"/>
                 <a:cs typeface="Aptos"/>
               </a:rPr>
-              <a:t>drives the wheels through the Waveshare HAT and stops if commands stop arriving</a:t>
+              <a:t>A missing library skips only that test</a:t>
             </a:r>
           </a:p>
           <a:p>
@@ -3851,17 +3927,6 @@
               <a:buChar char="•"/>
             </a:pPr>
             <a:r>
-              <a:rPr lang="en-US" sz="1600" b="1" dirty="0">
-                <a:solidFill>
-                  <a:srgbClr val="000000"/>
-                </a:solidFill>
-                <a:latin typeface="Aptos"/>
-                <a:ea typeface="Aptos"/>
-                <a:cs typeface="Aptos"/>
-              </a:rPr>
-              <a:t>LCD: </a:t>
-            </a:r>
-            <a:r>
               <a:rPr lang="en-US" sz="1600" b="0" dirty="0">
                 <a:solidFill>
                   <a:srgbClr val="000000"/>
@@ -3870,31 +3935,81 @@
                 <a:ea typeface="Aptos"/>
                 <a:cs typeface="Aptos"/>
               </a:rPr>
-              <a:t>shows the car’s state and the last sign detected</a:t>
-            </a:r>
-          </a:p>
-          <a:p>
-            <a:pPr marL="228600" indent="-228600" algn="l">
+              <a:t>--only and --skip run part of the suite on BuggyBot</a:t>
+            </a:r>
+          </a:p>
+        </p:txBody>
+      </p:sp>
+      <p:sp>
+        <p:nvSpPr>
+          <p:cNvPr id="8" name="Safety"/>
+          <p:cNvSpPr txBox="1"/>
+          <p:nvPr/>
+        </p:nvSpPr>
+        <p:spPr>
+          <a:xfrm>
+            <a:off x="7635240" y="3749040"/>
+            <a:ext cx="3794760" cy="384048"/>
+          </a:xfrm>
+          <a:prstGeom prst="rect">
+            <a:avLst/>
+          </a:prstGeom>
+          <a:noFill/>
+        </p:spPr>
+        <p:txBody>
+          <a:bodyPr wrap="square" lIns="0" tIns="0" rIns="0" bIns="0" anchor="t">
+            <a:noAutofit/>
+          </a:bodyPr>
+          <a:lstStyle/>
+          <a:p>
+            <a:pPr marL="0" indent="0" algn="l">
               <a:spcBef>
-                <a:spcPts val="700"/>
+                <a:spcPts val="0"/>
               </a:spcBef>
-              <a:buClr>
-                <a:srgbClr val="30669D"/>
-              </a:buClr>
-              <a:buFont typeface="Arial"/>
-              <a:buChar char="•"/>
+              <a:buNone/>
             </a:pPr>
             <a:r>
-              <a:rPr lang="en-US" sz="1600" b="1" dirty="0">
+              <a:rPr lang="en-US" sz="1950" b="1" dirty="0">
                 <a:solidFill>
-                  <a:srgbClr val="000000"/>
+                  <a:srgbClr val="30669D"/>
                 </a:solidFill>
                 <a:latin typeface="Aptos"/>
                 <a:ea typeface="Aptos"/>
                 <a:cs typeface="Aptos"/>
               </a:rPr>
-              <a:t>Teleop: </a:t>
-            </a:r>
+              <a:t>Safety</a:t>
+            </a:r>
+          </a:p>
+        </p:txBody>
+      </p:sp>
+      <p:sp>
+        <p:nvSpPr>
+          <p:cNvPr id="9" name="Safety text"/>
+          <p:cNvSpPr txBox="1"/>
+          <p:nvPr/>
+        </p:nvSpPr>
+        <p:spPr>
+          <a:xfrm>
+            <a:off x="7635240" y="4270248"/>
+            <a:ext cx="3794760" cy="1280160"/>
+          </a:xfrm>
+          <a:prstGeom prst="rect">
+            <a:avLst/>
+          </a:prstGeom>
+          <a:noFill/>
+        </p:spPr>
+        <p:txBody>
+          <a:bodyPr wrap="square" lIns="0" tIns="0" rIns="0" bIns="0" anchor="t">
+            <a:noAutofit/>
+          </a:bodyPr>
+          <a:lstStyle/>
+          <a:p>
+            <a:pPr marL="0" indent="0" algn="l">
+              <a:spcBef>
+                <a:spcPts val="0"/>
+              </a:spcBef>
+              <a:buNone/>
+            </a:pPr>
             <a:r>
               <a:rPr lang="en-US" sz="1600" b="0" dirty="0">
                 <a:solidFill>
@@ -3904,225 +4019,7 @@
                 <a:ea typeface="Aptos"/>
                 <a:cs typeface="Aptos"/>
               </a:rPr>
-              <a:t>lets a person take over and drive manually</a:t>
-            </a:r>
-          </a:p>
-        </p:txBody>
-      </p:sp>
-      <p:sp>
-        <p:nvSpPr>
-          <p:cNvPr id="6" name="Why ROS 2"/>
-          <p:cNvSpPr txBox="1"/>
-          <p:nvPr/>
-        </p:nvSpPr>
-        <p:spPr>
-          <a:xfrm>
-            <a:off x="7635240" y="1719072"/>
-            <a:ext cx="3794760" cy="384048"/>
-          </a:xfrm>
-          <a:prstGeom prst="rect">
-            <a:avLst/>
-          </a:prstGeom>
-          <a:noFill/>
-        </p:spPr>
-        <p:txBody>
-          <a:bodyPr wrap="square" lIns="0" tIns="0" rIns="0" bIns="0" anchor="t">
-            <a:noAutofit/>
-          </a:bodyPr>
-          <a:lstStyle/>
-          <a:p>
-            <a:pPr marL="0" indent="0" algn="l">
-              <a:spcBef>
-                <a:spcPts val="0"/>
-              </a:spcBef>
-              <a:buNone/>
-            </a:pPr>
-            <a:r>
-              <a:rPr lang="en-US" sz="1950" b="1" dirty="0">
-                <a:solidFill>
-                  <a:srgbClr val="30669D"/>
-                </a:solidFill>
-                <a:latin typeface="Aptos"/>
-                <a:ea typeface="Aptos"/>
-                <a:cs typeface="Aptos"/>
-              </a:rPr>
-              <a:t>Why ROS 2</a:t>
-            </a:r>
-          </a:p>
-        </p:txBody>
-      </p:sp>
-      <p:sp>
-        <p:nvSpPr>
-          <p:cNvPr id="7" name="Why ROS 2 list"/>
-          <p:cNvSpPr txBox="1"/>
-          <p:nvPr/>
-        </p:nvSpPr>
-        <p:spPr>
-          <a:xfrm>
-            <a:off x="7635240" y="2240280"/>
-            <a:ext cx="3794760" cy="2103120"/>
-          </a:xfrm>
-          <a:prstGeom prst="rect">
-            <a:avLst/>
-          </a:prstGeom>
-          <a:noFill/>
-        </p:spPr>
-        <p:txBody>
-          <a:bodyPr wrap="square" lIns="0" tIns="0" rIns="0" bIns="0" anchor="t">
-            <a:noAutofit/>
-          </a:bodyPr>
-          <a:lstStyle/>
-          <a:p>
-            <a:pPr marL="228600" indent="-228600" algn="l">
-              <a:spcBef>
-                <a:spcPts val="0"/>
-              </a:spcBef>
-              <a:buClr>
-                <a:srgbClr val="30669D"/>
-              </a:buClr>
-              <a:buFont typeface="Arial"/>
-              <a:buChar char="•"/>
-            </a:pPr>
-            <a:r>
-              <a:rPr lang="en-US" sz="1600" b="0" dirty="0">
-                <a:solidFill>
-                  <a:srgbClr val="000000"/>
-                </a:solidFill>
-                <a:latin typeface="Aptos"/>
-                <a:ea typeface="Aptos"/>
-                <a:cs typeface="Aptos"/>
-              </a:rPr>
-              <a:t>Each teammate can own a node without touching the others</a:t>
-            </a:r>
-          </a:p>
-          <a:p>
-            <a:pPr marL="228600" indent="-228600" algn="l">
-              <a:spcBef>
-                <a:spcPts val="900"/>
-              </a:spcBef>
-              <a:buClr>
-                <a:srgbClr val="30669D"/>
-              </a:buClr>
-              <a:buFont typeface="Arial"/>
-              <a:buChar char="•"/>
-            </a:pPr>
-            <a:r>
-              <a:rPr lang="en-US" sz="1600" b="0" dirty="0">
-                <a:solidFill>
-                  <a:srgbClr val="000000"/>
-                </a:solidFill>
-                <a:latin typeface="Aptos"/>
-                <a:ea typeface="Aptos"/>
-                <a:cs typeface="Aptos"/>
-              </a:rPr>
-              <a:t>Recorded drives can be replayed to test without the car</a:t>
-            </a:r>
-          </a:p>
-          <a:p>
-            <a:pPr marL="228600" indent="-228600" algn="l">
-              <a:spcBef>
-                <a:spcPts val="900"/>
-              </a:spcBef>
-              <a:buClr>
-                <a:srgbClr val="30669D"/>
-              </a:buClr>
-              <a:buFont typeface="Arial"/>
-              <a:buChar char="•"/>
-            </a:pPr>
-            <a:r>
-              <a:rPr lang="en-US" sz="1600" b="0" dirty="0">
-                <a:solidFill>
-                  <a:srgbClr val="000000"/>
-                </a:solidFill>
-                <a:latin typeface="Aptos"/>
-                <a:ea typeface="Aptos"/>
-                <a:cs typeface="Aptos"/>
-              </a:rPr>
-              <a:t>Laptops can watch the camera feed and topics live</a:t>
-            </a:r>
-          </a:p>
-        </p:txBody>
-      </p:sp>
-      <p:sp>
-        <p:nvSpPr>
-          <p:cNvPr id="8" name="Trade-off"/>
-          <p:cNvSpPr txBox="1"/>
-          <p:nvPr/>
-        </p:nvSpPr>
-        <p:spPr>
-          <a:xfrm>
-            <a:off x="7635240" y="4434840"/>
-            <a:ext cx="3794760" cy="384048"/>
-          </a:xfrm>
-          <a:prstGeom prst="rect">
-            <a:avLst/>
-          </a:prstGeom>
-          <a:noFill/>
-        </p:spPr>
-        <p:txBody>
-          <a:bodyPr wrap="square" lIns="0" tIns="0" rIns="0" bIns="0" anchor="t">
-            <a:noAutofit/>
-          </a:bodyPr>
-          <a:lstStyle/>
-          <a:p>
-            <a:pPr marL="0" indent="0" algn="l">
-              <a:spcBef>
-                <a:spcPts val="0"/>
-              </a:spcBef>
-              <a:buNone/>
-            </a:pPr>
-            <a:r>
-              <a:rPr lang="en-US" sz="1950" b="1" dirty="0">
-                <a:solidFill>
-                  <a:srgbClr val="30669D"/>
-                </a:solidFill>
-                <a:latin typeface="Aptos"/>
-                <a:ea typeface="Aptos"/>
-                <a:cs typeface="Aptos"/>
-              </a:rPr>
-              <a:t>Trade-off</a:t>
-            </a:r>
-          </a:p>
-        </p:txBody>
-      </p:sp>
-      <p:sp>
-        <p:nvSpPr>
-          <p:cNvPr id="9" name="Trade-off text"/>
-          <p:cNvSpPr txBox="1"/>
-          <p:nvPr/>
-        </p:nvSpPr>
-        <p:spPr>
-          <a:xfrm>
-            <a:off x="7635240" y="4956048"/>
-            <a:ext cx="3794760" cy="1280160"/>
-          </a:xfrm>
-          <a:prstGeom prst="rect">
-            <a:avLst/>
-          </a:prstGeom>
-          <a:noFill/>
-        </p:spPr>
-        <p:txBody>
-          <a:bodyPr wrap="square" lIns="0" tIns="0" rIns="0" bIns="0" anchor="t">
-            <a:noAutofit/>
-          </a:bodyPr>
-          <a:lstStyle/>
-          <a:p>
-            <a:pPr marL="0" indent="0" algn="l">
-              <a:spcBef>
-                <a:spcPts val="0"/>
-              </a:spcBef>
-              <a:buNone/>
-            </a:pPr>
-            <a:r>
-              <a:rPr lang="en-US" sz="1600" b="0" dirty="0">
-                <a:solidFill>
-                  <a:srgbClr val="000000"/>
-                </a:solidFill>
-                <a:latin typeface="Aptos"/>
-                <a:ea typeface="Aptos"/>
-                <a:cs typeface="Aptos"/>
-              </a:rPr>
-              <a:t>More upfront setup than a single script, including a custom Docker build for the CM5 camera</a:t>
+              <a:t>The motor test spins the wheels, so lift the car off the ground before running it</a:t>
             </a:r>
           </a:p>
         </p:txBody>
@@ -4184,7 +4081,7 @@
                 <a:ea typeface="Aptos Display"/>
                 <a:cs typeface="Aptos Display"/>
               </a:rPr>
-              <a:t>The behavior node makes every driving decision</a:t>
+              <a:t>Ran the ROS 2 turtlesim tutorial under WSL</a:t>
             </a:r>
           </a:p>
         </p:txBody>
@@ -4226,103 +4123,21 @@
                 <a:ea typeface="Aptos"/>
                 <a:cs typeface="Aptos"/>
               </a:rPr>
-              <a:t>Draft ROS 2 data flow: boxes are nodes, arrows are topics</a:t>
-            </a:r>
-          </a:p>
-        </p:txBody>
-      </p:sp>
-      <p:sp>
-        <p:nvSpPr>
-          <p:cNvPr id="4" name="Line sensor"/>
-          <p:cNvSpPr/>
+              <a:t>Separate ROS 2 nodes on my development computer, connected only through topics</a:t>
+            </a:r>
+          </a:p>
+        </p:txBody>
+      </p:sp>
+      <p:sp>
+        <p:nvSpPr>
+          <p:cNvPr id="6" name="Why"/>
+          <p:cNvSpPr txBox="1"/>
           <p:nvPr/>
         </p:nvSpPr>
         <p:spPr>
           <a:xfrm>
-            <a:off x="6766560" y="1691640"/>
-            <a:ext cx="1920240" cy="841248"/>
-          </a:xfrm>
-          <a:prstGeom prst="roundRect">
-            <a:avLst>
-              <a:gd name="adj" fmla="val 12000"/>
-            </a:avLst>
-          </a:prstGeom>
-          <a:solidFill>
-            <a:srgbClr val="F3F5F7"/>
-          </a:solidFill>
-          <a:ln w="12700">
-            <a:solidFill>
-              <a:srgbClr val="C9D1DA"/>
-            </a:solidFill>
-          </a:ln>
-        </p:spPr>
-        <p:txBody>
-          <a:bodyPr wrap="square" lIns="45720" tIns="45720" rIns="45720" bIns="45720" anchor="ctr">
-            <a:noAutofit/>
-          </a:bodyPr>
-          <a:lstStyle/>
-          <a:p>
-            <a:pPr algn="ctr"/>
-            <a:r>
-              <a:rPr lang="en-US" sz="1600" b="1" dirty="0">
-                <a:solidFill>
-                  <a:srgbClr val="22313F"/>
-                </a:solidFill>
-                <a:latin typeface="Aptos"/>
-                <a:ea typeface="Aptos"/>
-                <a:cs typeface="Aptos"/>
-              </a:rPr>
-              <a:t>Line sensor</a:t>
-            </a:r>
-          </a:p>
-          <a:p>
-            <a:pPr algn="ctr"/>
-            <a:r>
-              <a:rPr lang="en-US" sz="1200" b="0" dirty="0">
-                <a:solidFill>
-                  <a:srgbClr val="5B6773"/>
-                </a:solidFill>
-                <a:latin typeface="Aptos"/>
-                <a:ea typeface="Aptos"/>
-                <a:cs typeface="Aptos"/>
-              </a:rPr>
-              <a:t>TCRT5000 IR sensors</a:t>
-            </a:r>
-          </a:p>
-        </p:txBody>
-      </p:sp>
-      <p:cxnSp>
-        <p:nvCxnSpPr>
-          <p:cNvPr id="5" name="Arrow /lane"/>
-          <p:cNvCxnSpPr/>
-          <p:nvPr/>
-        </p:nvCxnSpPr>
-        <p:spPr>
-          <a:xfrm>
-            <a:off x="7726680" y="2578608"/>
-            <a:ext cx="0" cy="530352"/>
-          </a:xfrm>
-          <a:prstGeom prst="straightConnector1">
-            <a:avLst/>
-          </a:prstGeom>
-          <a:ln w="19050">
-            <a:solidFill>
-              <a:srgbClr val="5B6773"/>
-            </a:solidFill>
-            <a:tailEnd type="triangle" w="med" len="med"/>
-          </a:ln>
-        </p:spPr>
-      </p:cxnSp>
-      <p:sp>
-        <p:nvSpPr>
-          <p:cNvPr id="6" name="Topic /lane"/>
-          <p:cNvSpPr txBox="1"/>
-          <p:nvPr/>
-        </p:nvSpPr>
-        <p:spPr>
-          <a:xfrm>
-            <a:off x="7836408" y="2706624"/>
-            <a:ext cx="914400" cy="274320"/>
+            <a:off x="7635240" y="1719072"/>
+            <a:ext cx="3794760" cy="384048"/>
           </a:xfrm>
           <a:prstGeom prst="rect">
             <a:avLst/>
@@ -4330,7 +4145,7 @@
           <a:noFill/>
         </p:spPr>
         <p:txBody>
-          <a:bodyPr wrap="square" lIns="0" tIns="0" rIns="0" bIns="0" anchor="ctr">
+          <a:bodyPr wrap="square" lIns="0" tIns="0" rIns="0" bIns="0" anchor="t">
             <a:noAutofit/>
           </a:bodyPr>
           <a:lstStyle/>
@@ -4342,290 +4157,29 @@
               <a:buNone/>
             </a:pPr>
             <a:r>
-              <a:rPr lang="en-US" sz="1100" b="0" dirty="0">
+              <a:rPr lang="en-US" sz="1950" b="1" dirty="0">
                 <a:solidFill>
-                  <a:srgbClr val="5B6773"/>
-                </a:solidFill>
-                <a:latin typeface="Courier New"/>
-                <a:cs typeface="Courier New"/>
-              </a:rPr>
-              <a:t>/lane</a:t>
-            </a:r>
-          </a:p>
-        </p:txBody>
-      </p:sp>
-      <p:sp>
-        <p:nvSpPr>
-          <p:cNvPr id="7" name="Camera"/>
-          <p:cNvSpPr/>
-          <p:nvPr/>
-        </p:nvSpPr>
-        <p:spPr>
-          <a:xfrm>
-            <a:off x="786384" y="3154680"/>
-            <a:ext cx="1920240" cy="841248"/>
-          </a:xfrm>
-          <a:prstGeom prst="roundRect">
-            <a:avLst>
-              <a:gd name="adj" fmla="val 12000"/>
-            </a:avLst>
-          </a:prstGeom>
-          <a:solidFill>
-            <a:srgbClr val="F3F5F7"/>
-          </a:solidFill>
-          <a:ln w="12700">
-            <a:solidFill>
-              <a:srgbClr val="C9D1DA"/>
-            </a:solidFill>
-          </a:ln>
-        </p:spPr>
-        <p:txBody>
-          <a:bodyPr wrap="square" lIns="45720" tIns="45720" rIns="45720" bIns="45720" anchor="ctr">
-            <a:noAutofit/>
-          </a:bodyPr>
-          <a:lstStyle/>
-          <a:p>
-            <a:pPr algn="ctr"/>
-            <a:r>
-              <a:rPr lang="en-US" sz="1600" b="1" dirty="0">
-                <a:solidFill>
-                  <a:srgbClr val="22313F"/>
+                  <a:srgbClr val="30669D"/>
                 </a:solidFill>
                 <a:latin typeface="Aptos"/>
                 <a:ea typeface="Aptos"/>
                 <a:cs typeface="Aptos"/>
               </a:rPr>
-              <a:t>Camera</a:t>
-            </a:r>
-          </a:p>
-          <a:p>
-            <a:pPr algn="ctr"/>
-            <a:r>
-              <a:rPr lang="en-US" sz="1200" b="0" dirty="0">
-                <a:solidFill>
-                  <a:srgbClr val="5B6773"/>
-                </a:solidFill>
-                <a:latin typeface="Aptos"/>
-                <a:ea typeface="Aptos"/>
-                <a:cs typeface="Aptos"/>
-              </a:rPr>
-              <a:t>Pi Camera Module 3</a:t>
-            </a:r>
-          </a:p>
-        </p:txBody>
-      </p:sp>
-      <p:sp>
-        <p:nvSpPr>
-          <p:cNvPr id="8" name="Sign detector"/>
-          <p:cNvSpPr/>
+              <a:t>What’s running</a:t>
+            </a:r>
+          </a:p>
+        </p:txBody>
+      </p:sp>
+      <p:sp>
+        <p:nvSpPr>
+          <p:cNvPr id="7" name="Why list"/>
+          <p:cNvSpPr txBox="1"/>
           <p:nvPr/>
         </p:nvSpPr>
         <p:spPr>
           <a:xfrm>
-            <a:off x="3776472" y="3154680"/>
-            <a:ext cx="1920240" cy="841248"/>
-          </a:xfrm>
-          <a:prstGeom prst="roundRect">
-            <a:avLst>
-              <a:gd name="adj" fmla="val 12000"/>
-            </a:avLst>
-          </a:prstGeom>
-          <a:solidFill>
-            <a:srgbClr val="F3F5F7"/>
-          </a:solidFill>
-          <a:ln w="12700">
-            <a:solidFill>
-              <a:srgbClr val="C9D1DA"/>
-            </a:solidFill>
-          </a:ln>
-        </p:spPr>
-        <p:txBody>
-          <a:bodyPr wrap="square" lIns="45720" tIns="45720" rIns="45720" bIns="45720" anchor="ctr">
-            <a:noAutofit/>
-          </a:bodyPr>
-          <a:lstStyle/>
-          <a:p>
-            <a:pPr algn="ctr"/>
-            <a:r>
-              <a:rPr lang="en-US" sz="1600" b="1" dirty="0">
-                <a:solidFill>
-                  <a:srgbClr val="22313F"/>
-                </a:solidFill>
-                <a:latin typeface="Aptos"/>
-                <a:ea typeface="Aptos"/>
-                <a:cs typeface="Aptos"/>
-              </a:rPr>
-              <a:t>Sign detector</a:t>
-            </a:r>
-          </a:p>
-          <a:p>
-            <a:pPr algn="ctr"/>
-            <a:r>
-              <a:rPr lang="en-US" sz="1200" b="0" dirty="0">
-                <a:solidFill>
-                  <a:srgbClr val="5B6773"/>
-                </a:solidFill>
-                <a:latin typeface="Aptos"/>
-                <a:ea typeface="Aptos"/>
-                <a:cs typeface="Aptos"/>
-              </a:rPr>
-              <a:t>Vision model</a:t>
-            </a:r>
-          </a:p>
-        </p:txBody>
-      </p:sp>
-      <p:sp>
-        <p:nvSpPr>
-          <p:cNvPr id="9" name="Behavior"/>
-          <p:cNvSpPr/>
-          <p:nvPr/>
-        </p:nvSpPr>
-        <p:spPr>
-          <a:xfrm>
-            <a:off x="6766560" y="3154680"/>
-            <a:ext cx="1920240" cy="841248"/>
-          </a:xfrm>
-          <a:prstGeom prst="roundRect">
-            <a:avLst>
-              <a:gd name="adj" fmla="val 12000"/>
-            </a:avLst>
-          </a:prstGeom>
-          <a:solidFill>
-            <a:srgbClr val="30669D"/>
-          </a:solidFill>
-          <a:ln w="12700">
-            <a:solidFill>
-              <a:srgbClr val="30669D"/>
-            </a:solidFill>
-          </a:ln>
-        </p:spPr>
-        <p:txBody>
-          <a:bodyPr wrap="square" lIns="45720" tIns="45720" rIns="45720" bIns="45720" anchor="ctr">
-            <a:noAutofit/>
-          </a:bodyPr>
-          <a:lstStyle/>
-          <a:p>
-            <a:pPr algn="ctr"/>
-            <a:r>
-              <a:rPr lang="en-US" sz="1600" b="1" dirty="0">
-                <a:solidFill>
-                  <a:srgbClr val="FFFFFF"/>
-                </a:solidFill>
-                <a:latin typeface="Aptos"/>
-                <a:ea typeface="Aptos"/>
-                <a:cs typeface="Aptos"/>
-              </a:rPr>
-              <a:t>Behavior</a:t>
-            </a:r>
-          </a:p>
-          <a:p>
-            <a:pPr algn="ctr"/>
-            <a:r>
-              <a:rPr lang="en-US" sz="1200" b="0" dirty="0">
-                <a:solidFill>
-                  <a:srgbClr val="DCE6F1"/>
-                </a:solidFill>
-                <a:latin typeface="Aptos"/>
-                <a:ea typeface="Aptos"/>
-                <a:cs typeface="Aptos"/>
-              </a:rPr>
-              <a:t>State machine</a:t>
-            </a:r>
-          </a:p>
-        </p:txBody>
-      </p:sp>
-      <p:sp>
-        <p:nvSpPr>
-          <p:cNvPr id="10" name="Motor driver"/>
-          <p:cNvSpPr/>
-          <p:nvPr/>
-        </p:nvSpPr>
-        <p:spPr>
-          <a:xfrm>
-            <a:off x="9756648" y="3154680"/>
-            <a:ext cx="1920240" cy="841248"/>
-          </a:xfrm>
-          <a:prstGeom prst="roundRect">
-            <a:avLst>
-              <a:gd name="adj" fmla="val 12000"/>
-            </a:avLst>
-          </a:prstGeom>
-          <a:solidFill>
-            <a:srgbClr val="F3F5F7"/>
-          </a:solidFill>
-          <a:ln w="12700">
-            <a:solidFill>
-              <a:srgbClr val="C9D1DA"/>
-            </a:solidFill>
-          </a:ln>
-        </p:spPr>
-        <p:txBody>
-          <a:bodyPr wrap="square" lIns="45720" tIns="45720" rIns="45720" bIns="45720" anchor="ctr">
-            <a:noAutofit/>
-          </a:bodyPr>
-          <a:lstStyle/>
-          <a:p>
-            <a:pPr algn="ctr"/>
-            <a:r>
-              <a:rPr lang="en-US" sz="1600" b="1" dirty="0">
-                <a:solidFill>
-                  <a:srgbClr val="22313F"/>
-                </a:solidFill>
-                <a:latin typeface="Aptos"/>
-                <a:ea typeface="Aptos"/>
-                <a:cs typeface="Aptos"/>
-              </a:rPr>
-              <a:t>Motor driver</a:t>
-            </a:r>
-          </a:p>
-          <a:p>
-            <a:pPr algn="ctr"/>
-            <a:r>
-              <a:rPr lang="en-US" sz="1200" b="0" dirty="0">
-                <a:solidFill>
-                  <a:srgbClr val="5B6773"/>
-                </a:solidFill>
-                <a:latin typeface="Aptos"/>
-                <a:ea typeface="Aptos"/>
-                <a:cs typeface="Aptos"/>
-              </a:rPr>
-              <a:t>Waveshare HAT (I2C)</a:t>
-            </a:r>
-          </a:p>
-        </p:txBody>
-      </p:sp>
-      <p:cxnSp>
-        <p:nvCxnSpPr>
-          <p:cNvPr id="11" name="Arrow /image_raw"/>
-          <p:cNvCxnSpPr/>
-          <p:nvPr/>
-        </p:nvCxnSpPr>
-        <p:spPr>
-          <a:xfrm>
-            <a:off x="2752344" y="3575304"/>
-            <a:ext cx="978408" cy="0"/>
-          </a:xfrm>
-          <a:prstGeom prst="straightConnector1">
-            <a:avLst/>
-          </a:prstGeom>
-          <a:ln w="19050">
-            <a:solidFill>
-              <a:srgbClr val="5B6773"/>
-            </a:solidFill>
-            <a:tailEnd type="triangle" w="med" len="med"/>
-          </a:ln>
-        </p:spPr>
-      </p:cxnSp>
-      <p:sp>
-        <p:nvSpPr>
-          <p:cNvPr id="12" name="Topic /image_raw"/>
-          <p:cNvSpPr txBox="1"/>
-          <p:nvPr/>
-        </p:nvSpPr>
-        <p:spPr>
-          <a:xfrm>
-            <a:off x="2752344" y="3191256"/>
-            <a:ext cx="978408" cy="274320"/>
+            <a:off x="7635240" y="2240280"/>
+            <a:ext cx="3794760" cy="1874520"/>
           </a:xfrm>
           <a:prstGeom prst="rect">
             <a:avLst/>
@@ -4633,62 +4187,124 @@
           <a:noFill/>
         </p:spPr>
         <p:txBody>
-          <a:bodyPr wrap="square" lIns="0" tIns="0" rIns="0" bIns="0" anchor="ctr">
+          <a:bodyPr wrap="square" lIns="0" tIns="0" rIns="0" bIns="0" anchor="t">
             <a:noAutofit/>
           </a:bodyPr>
           <a:lstStyle/>
           <a:p>
-            <a:pPr marL="0" indent="0" algn="ctr">
+            <a:pPr marL="228600" indent="-228600" algn="l">
               <a:spcBef>
                 <a:spcPts val="0"/>
               </a:spcBef>
-              <a:buNone/>
+              <a:buClr>
+                <a:srgbClr val="30669D"/>
+              </a:buClr>
+              <a:buFont typeface="Arial"/>
+              <a:buChar char="•"/>
             </a:pPr>
             <a:r>
-              <a:rPr lang="en-US" sz="1100" b="0" dirty="0">
+              <a:rPr lang="en-US" sz="1600" b="1" dirty="0">
                 <a:solidFill>
-                  <a:srgbClr val="5B6773"/>
+                  <a:srgbClr val="000000"/>
                 </a:solidFill>
-                <a:latin typeface="Courier New"/>
-                <a:cs typeface="Courier New"/>
+                <a:latin typeface="Aptos"/>
+                <a:ea typeface="Aptos"/>
+                <a:cs typeface="Aptos"/>
               </a:rPr>
-              <a:t>/image_raw</a:t>
-            </a:r>
-          </a:p>
-        </p:txBody>
-      </p:sp>
-      <p:cxnSp>
-        <p:nvCxnSpPr>
-          <p:cNvPr id="13" name="Arrow /signs"/>
-          <p:cNvCxnSpPr/>
+              <a:t>turtlesim_node: </a:t>
+            </a:r>
+            <a:r>
+              <a:rPr lang="en-US" sz="1600" b="0" dirty="0">
+                <a:solidFill>
+                  <a:srgbClr val="000000"/>
+                </a:solidFill>
+                <a:latin typeface="Aptos"/>
+                <a:ea typeface="Aptos"/>
+                <a:cs typeface="Aptos"/>
+              </a:rPr>
+              <a:t>draws the simulator window</a:t>
+            </a:r>
+          </a:p>
+          <a:p>
+            <a:pPr marL="228600" indent="-228600" algn="l">
+              <a:spcBef>
+                <a:spcPts val="700"/>
+              </a:spcBef>
+              <a:buClr>
+                <a:srgbClr val="30669D"/>
+              </a:buClr>
+              <a:buFont typeface="Arial"/>
+              <a:buChar char="•"/>
+            </a:pPr>
+            <a:r>
+              <a:rPr lang="en-US" sz="1600" b="1" dirty="0">
+                <a:solidFill>
+                  <a:srgbClr val="000000"/>
+                </a:solidFill>
+                <a:latin typeface="Aptos"/>
+                <a:ea typeface="Aptos"/>
+                <a:cs typeface="Aptos"/>
+              </a:rPr>
+              <a:t>turtle_teleop_key: </a:t>
+            </a:r>
+            <a:r>
+              <a:rPr lang="en-US" sz="1600" b="0" dirty="0">
+                <a:solidFill>
+                  <a:srgbClr val="000000"/>
+                </a:solidFill>
+                <a:latin typeface="Aptos"/>
+                <a:ea typeface="Aptos"/>
+                <a:cs typeface="Aptos"/>
+              </a:rPr>
+              <a:t>publishes velocity commands from the arrow keys</a:t>
+            </a:r>
+          </a:p>
+          <a:p>
+            <a:pPr marL="228600" indent="-228600" algn="l">
+              <a:spcBef>
+                <a:spcPts val="700"/>
+              </a:spcBef>
+              <a:buClr>
+                <a:srgbClr val="30669D"/>
+              </a:buClr>
+              <a:buFont typeface="Arial"/>
+              <a:buChar char="•"/>
+            </a:pPr>
+            <a:r>
+              <a:rPr lang="en-US" sz="1600" b="1" dirty="0">
+                <a:solidFill>
+                  <a:srgbClr val="000000"/>
+                </a:solidFill>
+                <a:latin typeface="Aptos"/>
+                <a:ea typeface="Aptos"/>
+                <a:cs typeface="Aptos"/>
+              </a:rPr>
+              <a:t>Pose topic: </a:t>
+            </a:r>
+            <a:r>
+              <a:rPr lang="en-US" sz="1600" b="0" dirty="0">
+                <a:solidFill>
+                  <a:srgbClr val="000000"/>
+                </a:solidFill>
+                <a:latin typeface="Aptos"/>
+                <a:ea typeface="Aptos"/>
+                <a:cs typeface="Aptos"/>
+              </a:rPr>
+              <a:t>a third terminal prints the turtle’s position and heading</a:t>
+            </a:r>
+          </a:p>
+        </p:txBody>
+      </p:sp>
+      <p:sp>
+        <p:nvSpPr>
+          <p:cNvPr id="8" name="Safety"/>
+          <p:cNvSpPr txBox="1"/>
           <p:nvPr/>
-        </p:nvCxnSpPr>
+        </p:nvSpPr>
         <p:spPr>
           <a:xfrm>
-            <a:off x="5742432" y="3575304"/>
-            <a:ext cx="978408" cy="0"/>
-          </a:xfrm>
-          <a:prstGeom prst="straightConnector1">
-            <a:avLst/>
-          </a:prstGeom>
-          <a:ln w="19050">
-            <a:solidFill>
-              <a:srgbClr val="5B6773"/>
-            </a:solidFill>
-            <a:tailEnd type="triangle" w="med" len="med"/>
-          </a:ln>
-        </p:spPr>
-      </p:cxnSp>
-      <p:sp>
-        <p:nvSpPr>
-          <p:cNvPr id="14" name="Topic /signs"/>
-          <p:cNvSpPr txBox="1"/>
-          <p:nvPr/>
-        </p:nvSpPr>
-        <p:spPr>
-          <a:xfrm>
-            <a:off x="5742432" y="3191256"/>
-            <a:ext cx="978408" cy="274320"/>
+            <a:off x="7635240" y="4251960"/>
+            <a:ext cx="3794760" cy="384048"/>
           </a:xfrm>
           <a:prstGeom prst="rect">
             <a:avLst/>
@@ -4696,62 +4312,41 @@
           <a:noFill/>
         </p:spPr>
         <p:txBody>
-          <a:bodyPr wrap="square" lIns="0" tIns="0" rIns="0" bIns="0" anchor="ctr">
+          <a:bodyPr wrap="square" lIns="0" tIns="0" rIns="0" bIns="0" anchor="t">
             <a:noAutofit/>
           </a:bodyPr>
           <a:lstStyle/>
           <a:p>
-            <a:pPr marL="0" indent="0" algn="ctr">
+            <a:pPr marL="0" indent="0" algn="l">
               <a:spcBef>
                 <a:spcPts val="0"/>
               </a:spcBef>
               <a:buNone/>
             </a:pPr>
             <a:r>
-              <a:rPr lang="en-US" sz="1100" b="0" dirty="0">
+              <a:rPr lang="en-US" sz="1950" b="1" dirty="0">
                 <a:solidFill>
-                  <a:srgbClr val="5B6773"/>
+                  <a:srgbClr val="30669D"/>
                 </a:solidFill>
-                <a:latin typeface="Courier New"/>
-                <a:cs typeface="Courier New"/>
+                <a:latin typeface="Aptos"/>
+                <a:ea typeface="Aptos"/>
+                <a:cs typeface="Aptos"/>
               </a:rPr>
-              <a:t>/signs</a:t>
-            </a:r>
-          </a:p>
-        </p:txBody>
-      </p:sp>
-      <p:cxnSp>
-        <p:nvCxnSpPr>
-          <p:cNvPr id="15" name="Arrow /cmd_vel"/>
-          <p:cNvCxnSpPr/>
+              <a:t>Why it matters</a:t>
+            </a:r>
+          </a:p>
+        </p:txBody>
+      </p:sp>
+      <p:sp>
+        <p:nvSpPr>
+          <p:cNvPr id="9" name="Safety text"/>
+          <p:cNvSpPr txBox="1"/>
           <p:nvPr/>
-        </p:nvCxnSpPr>
+        </p:nvSpPr>
         <p:spPr>
           <a:xfrm>
-            <a:off x="8732520" y="3575304"/>
-            <a:ext cx="978408" cy="0"/>
-          </a:xfrm>
-          <a:prstGeom prst="straightConnector1">
-            <a:avLst/>
-          </a:prstGeom>
-          <a:ln w="19050">
-            <a:solidFill>
-              <a:srgbClr val="5B6773"/>
-            </a:solidFill>
-            <a:tailEnd type="triangle" w="med" len="med"/>
-          </a:ln>
-        </p:spPr>
-      </p:cxnSp>
-      <p:sp>
-        <p:nvSpPr>
-          <p:cNvPr id="16" name="Topic /cmd_vel"/>
-          <p:cNvSpPr txBox="1"/>
-          <p:nvPr/>
-        </p:nvSpPr>
-        <p:spPr>
-          <a:xfrm>
-            <a:off x="8732520" y="3191256"/>
-            <a:ext cx="978408" cy="274320"/>
+            <a:off x="7635240" y="4773168"/>
+            <a:ext cx="3794760" cy="1280160"/>
           </a:xfrm>
           <a:prstGeom prst="rect">
             <a:avLst/>
@@ -4759,440 +4354,60 @@
           <a:noFill/>
         </p:spPr>
         <p:txBody>
-          <a:bodyPr wrap="square" lIns="0" tIns="0" rIns="0" bIns="0" anchor="ctr">
+          <a:bodyPr wrap="square" lIns="0" tIns="0" rIns="0" bIns="0" anchor="t">
             <a:noAutofit/>
           </a:bodyPr>
           <a:lstStyle/>
           <a:p>
-            <a:pPr marL="0" indent="0" algn="ctr">
+            <a:pPr marL="0" indent="0" algn="l">
               <a:spcBef>
                 <a:spcPts val="0"/>
               </a:spcBef>
               <a:buNone/>
             </a:pPr>
             <a:r>
-              <a:rPr lang="en-US" sz="1100" b="0" dirty="0">
+              <a:rPr lang="en-US" sz="1600" b="0" dirty="0">
                 <a:solidFill>
-                  <a:srgbClr val="5B6773"/>
-                </a:solidFill>
-                <a:latin typeface="Courier New"/>
-                <a:cs typeface="Courier New"/>
-              </a:rPr>
-              <a:t>/cmd_vel</a:t>
-            </a:r>
-          </a:p>
-        </p:txBody>
-      </p:sp>
-      <p:sp>
-        <p:nvSpPr>
-          <p:cNvPr id="17" name="IMU"/>
-          <p:cNvSpPr/>
-          <p:nvPr/>
-        </p:nvSpPr>
-        <p:spPr>
-          <a:xfrm>
-            <a:off x="3776472" y="5120640"/>
-            <a:ext cx="1920240" cy="841248"/>
-          </a:xfrm>
-          <a:prstGeom prst="roundRect">
-            <a:avLst>
-              <a:gd name="adj" fmla="val 12000"/>
-            </a:avLst>
-          </a:prstGeom>
-          <a:solidFill>
-            <a:srgbClr val="F3F5F7"/>
-          </a:solidFill>
-          <a:ln w="12700">
-            <a:solidFill>
-              <a:srgbClr val="C9D1DA"/>
-            </a:solidFill>
-          </a:ln>
-        </p:spPr>
-        <p:txBody>
-          <a:bodyPr wrap="square" lIns="45720" tIns="45720" rIns="45720" bIns="45720" anchor="ctr">
-            <a:noAutofit/>
-          </a:bodyPr>
-          <a:lstStyle/>
-          <a:p>
-            <a:pPr algn="ctr"/>
-            <a:r>
-              <a:rPr lang="en-US" sz="1600" b="1" dirty="0">
-                <a:solidFill>
-                  <a:srgbClr val="22313F"/>
+                  <a:srgbClr val="000000"/>
                 </a:solidFill>
                 <a:latin typeface="Aptos"/>
                 <a:ea typeface="Aptos"/>
                 <a:cs typeface="Aptos"/>
               </a:rPr>
-              <a:t>IMU</a:t>
-            </a:r>
-          </a:p>
-          <a:p>
-            <a:pPr algn="ctr"/>
-            <a:r>
-              <a:rPr lang="en-US" sz="1200" b="0" dirty="0">
-                <a:solidFill>
-                  <a:srgbClr val="5B6773"/>
-                </a:solidFill>
-                <a:latin typeface="Aptos"/>
-                <a:ea typeface="Aptos"/>
-                <a:cs typeface="Aptos"/>
-              </a:rPr>
-              <a:t>IMU (I2C)</a:t>
-            </a:r>
-          </a:p>
-        </p:txBody>
-      </p:sp>
-      <p:sp>
-        <p:nvSpPr>
-          <p:cNvPr id="18" name="LCD"/>
-          <p:cNvSpPr/>
+              <a:t>The car’s nodes will work the same way: one node publishes a topic and others subscribe to it</a:t>
+            </a:r>
+          </a:p>
+        </p:txBody>
+      </p:sp>
+      <p:pic>
+        <p:nvPicPr>
+          <p:cNvPr id="20" name="Turtlesim screenshot" descr="Turtlesim window with the turtle’s drawn path, beside terminals running turtlesim_node, turtle_teleop_key and the turtle pose readout"/>
+          <p:cNvPicPr>
+            <a:picLocks noChangeAspect="1"/>
+          </p:cNvPicPr>
           <p:nvPr/>
-        </p:nvSpPr>
+        </p:nvPicPr>
+        <p:blipFill>
+          <a:blip r:embed="rId2"/>
+          <a:stretch>
+            <a:fillRect/>
+          </a:stretch>
+        </p:blipFill>
         <p:spPr>
           <a:xfrm>
-            <a:off x="6766560" y="5120640"/>
-            <a:ext cx="1920240" cy="841248"/>
-          </a:xfrm>
-          <a:prstGeom prst="roundRect">
-            <a:avLst>
-              <a:gd name="adj" fmla="val 12000"/>
-            </a:avLst>
-          </a:prstGeom>
-          <a:solidFill>
-            <a:srgbClr val="F3F5F7"/>
-          </a:solidFill>
-          <a:ln w="12700">
-            <a:solidFill>
-              <a:srgbClr val="C9D1DA"/>
-            </a:solidFill>
-          </a:ln>
-        </p:spPr>
-        <p:txBody>
-          <a:bodyPr wrap="square" lIns="45720" tIns="45720" rIns="45720" bIns="45720" anchor="ctr">
-            <a:noAutofit/>
-          </a:bodyPr>
-          <a:lstStyle/>
-          <a:p>
-            <a:pPr algn="ctr"/>
-            <a:r>
-              <a:rPr lang="en-US" sz="1600" b="1" dirty="0">
-                <a:solidFill>
-                  <a:srgbClr val="22313F"/>
-                </a:solidFill>
-                <a:latin typeface="Aptos"/>
-                <a:ea typeface="Aptos"/>
-                <a:cs typeface="Aptos"/>
-              </a:rPr>
-              <a:t>LCD</a:t>
-            </a:r>
-          </a:p>
-          <a:p>
-            <a:pPr algn="ctr"/>
-            <a:r>
-              <a:rPr lang="en-US" sz="1200" b="0" dirty="0">
-                <a:solidFill>
-                  <a:srgbClr val="5B6773"/>
-                </a:solidFill>
-                <a:latin typeface="Aptos"/>
-                <a:ea typeface="Aptos"/>
-                <a:cs typeface="Aptos"/>
-              </a:rPr>
-              <a:t>LCD display (I2C)</a:t>
-            </a:r>
-          </a:p>
-        </p:txBody>
-      </p:sp>
-      <p:sp>
-        <p:nvSpPr>
-          <p:cNvPr id="19" name="Teleop"/>
-          <p:cNvSpPr/>
-          <p:nvPr/>
-        </p:nvSpPr>
-        <p:spPr>
-          <a:xfrm>
-            <a:off x="9756648" y="5120640"/>
-            <a:ext cx="1920240" cy="841248"/>
-          </a:xfrm>
-          <a:prstGeom prst="roundRect">
-            <a:avLst>
-              <a:gd name="adj" fmla="val 12000"/>
-            </a:avLst>
-          </a:prstGeom>
-          <a:solidFill>
-            <a:srgbClr val="F3F5F7"/>
-          </a:solidFill>
-          <a:ln w="12700">
-            <a:solidFill>
-              <a:srgbClr val="C9D1DA"/>
-            </a:solidFill>
-          </a:ln>
-        </p:spPr>
-        <p:txBody>
-          <a:bodyPr wrap="square" lIns="45720" tIns="45720" rIns="45720" bIns="45720" anchor="ctr">
-            <a:noAutofit/>
-          </a:bodyPr>
-          <a:lstStyle/>
-          <a:p>
-            <a:pPr algn="ctr"/>
-            <a:r>
-              <a:rPr lang="en-US" sz="1600" b="1" dirty="0">
-                <a:solidFill>
-                  <a:srgbClr val="22313F"/>
-                </a:solidFill>
-                <a:latin typeface="Aptos"/>
-                <a:ea typeface="Aptos"/>
-                <a:cs typeface="Aptos"/>
-              </a:rPr>
-              <a:t>Teleop</a:t>
-            </a:r>
-          </a:p>
-          <a:p>
-            <a:pPr algn="ctr"/>
-            <a:r>
-              <a:rPr lang="en-US" sz="1200" b="0" dirty="0">
-                <a:solidFill>
-                  <a:srgbClr val="5B6773"/>
-                </a:solidFill>
-                <a:latin typeface="Aptos"/>
-                <a:ea typeface="Aptos"/>
-                <a:cs typeface="Aptos"/>
-              </a:rPr>
-              <a:t>Laptop keyboard</a:t>
-            </a:r>
-          </a:p>
-        </p:txBody>
-      </p:sp>
-      <p:cxnSp>
-        <p:nvCxnSpPr>
-          <p:cNvPr id="20" name="Arrow /imu"/>
-          <p:cNvCxnSpPr/>
-          <p:nvPr/>
-        </p:nvCxnSpPr>
-        <p:spPr>
-          <a:xfrm flipV="1">
-            <a:off x="5468112" y="4041648"/>
-            <a:ext cx="1618488" cy="1033272"/>
-          </a:xfrm>
-          <a:prstGeom prst="straightConnector1">
-            <a:avLst/>
-          </a:prstGeom>
-          <a:ln w="19050">
-            <a:solidFill>
-              <a:srgbClr val="5B6773"/>
-            </a:solidFill>
-            <a:tailEnd type="triangle" w="med" len="med"/>
-          </a:ln>
-        </p:spPr>
-      </p:cxnSp>
-      <p:sp>
-        <p:nvSpPr>
-          <p:cNvPr id="21" name="Topic /imu"/>
-          <p:cNvSpPr txBox="1"/>
-          <p:nvPr/>
-        </p:nvSpPr>
-        <p:spPr>
-          <a:xfrm>
-            <a:off x="6551676" y="4512564"/>
-            <a:ext cx="640080" cy="274320"/>
+            <a:off x="786384" y="1719072"/>
+            <a:ext cx="6309360" cy="3578401"/>
           </a:xfrm>
           <a:prstGeom prst="rect">
             <a:avLst/>
           </a:prstGeom>
-          <a:noFill/>
-        </p:spPr>
-        <p:txBody>
-          <a:bodyPr wrap="square" lIns="0" tIns="0" rIns="0" bIns="0" anchor="ctr">
-            <a:noAutofit/>
-          </a:bodyPr>
-          <a:lstStyle/>
-          <a:p>
-            <a:pPr marL="0" indent="0" algn="l">
-              <a:spcBef>
-                <a:spcPts val="0"/>
-              </a:spcBef>
-              <a:buNone/>
-            </a:pPr>
-            <a:r>
-              <a:rPr lang="en-US" sz="1100" b="0" dirty="0">
-                <a:solidFill>
-                  <a:srgbClr val="5B6773"/>
-                </a:solidFill>
-                <a:latin typeface="Courier New"/>
-                <a:cs typeface="Courier New"/>
-              </a:rPr>
-              <a:t>/imu</a:t>
-            </a:r>
-          </a:p>
-        </p:txBody>
-      </p:sp>
-      <p:cxnSp>
-        <p:nvCxnSpPr>
-          <p:cNvPr id="22" name="Arrow /status"/>
-          <p:cNvCxnSpPr/>
-          <p:nvPr/>
-        </p:nvCxnSpPr>
-        <p:spPr>
-          <a:xfrm>
-            <a:off x="7955280" y="4041648"/>
-            <a:ext cx="0" cy="1033272"/>
-          </a:xfrm>
-          <a:prstGeom prst="straightConnector1">
-            <a:avLst/>
-          </a:prstGeom>
-          <a:ln w="19050">
+          <a:ln w="9525">
             <a:solidFill>
-              <a:srgbClr val="5B6773"/>
+              <a:srgbClr val="BFBFBF"/>
             </a:solidFill>
-            <a:tailEnd type="triangle" w="med" len="med"/>
           </a:ln>
         </p:spPr>
-      </p:cxnSp>
-      <p:sp>
-        <p:nvSpPr>
-          <p:cNvPr id="23" name="Topic /status"/>
-          <p:cNvSpPr txBox="1"/>
-          <p:nvPr/>
-        </p:nvSpPr>
-        <p:spPr>
-          <a:xfrm>
-            <a:off x="8065008" y="4421124"/>
-            <a:ext cx="914400" cy="274320"/>
-          </a:xfrm>
-          <a:prstGeom prst="rect">
-            <a:avLst/>
-          </a:prstGeom>
-          <a:noFill/>
-        </p:spPr>
-        <p:txBody>
-          <a:bodyPr wrap="square" lIns="0" tIns="0" rIns="0" bIns="0" anchor="ctr">
-            <a:noAutofit/>
-          </a:bodyPr>
-          <a:lstStyle/>
-          <a:p>
-            <a:pPr marL="0" indent="0" algn="l">
-              <a:spcBef>
-                <a:spcPts val="0"/>
-              </a:spcBef>
-              <a:buNone/>
-            </a:pPr>
-            <a:r>
-              <a:rPr lang="en-US" sz="1100" b="0" dirty="0">
-                <a:solidFill>
-                  <a:srgbClr val="5B6773"/>
-                </a:solidFill>
-                <a:latin typeface="Courier New"/>
-                <a:cs typeface="Courier New"/>
-              </a:rPr>
-              <a:t>/status</a:t>
-            </a:r>
-          </a:p>
-        </p:txBody>
-      </p:sp>
-      <p:cxnSp>
-        <p:nvCxnSpPr>
-          <p:cNvPr id="24" name="Arrow teleop"/>
-          <p:cNvCxnSpPr/>
-          <p:nvPr/>
-        </p:nvCxnSpPr>
-        <p:spPr>
-          <a:xfrm flipV="1">
-            <a:off x="10716768" y="4041648"/>
-            <a:ext cx="0" cy="1033272"/>
-          </a:xfrm>
-          <a:prstGeom prst="straightConnector1">
-            <a:avLst/>
-          </a:prstGeom>
-          <a:ln w="19050">
-            <a:solidFill>
-              <a:srgbClr val="5B6773"/>
-            </a:solidFill>
-            <a:tailEnd type="triangle" w="med" len="med"/>
-          </a:ln>
-        </p:spPr>
-      </p:cxnSp>
-      <p:sp>
-        <p:nvSpPr>
-          <p:cNvPr id="25" name="Topic /cmd_vel"/>
-          <p:cNvSpPr txBox="1"/>
-          <p:nvPr/>
-        </p:nvSpPr>
-        <p:spPr>
-          <a:xfrm>
-            <a:off x="10826496" y="4265676"/>
-            <a:ext cx="914400" cy="274320"/>
-          </a:xfrm>
-          <a:prstGeom prst="rect">
-            <a:avLst/>
-          </a:prstGeom>
-          <a:noFill/>
-        </p:spPr>
-        <p:txBody>
-          <a:bodyPr wrap="square" lIns="0" tIns="0" rIns="0" bIns="0" anchor="ctr">
-            <a:noAutofit/>
-          </a:bodyPr>
-          <a:lstStyle/>
-          <a:p>
-            <a:pPr marL="0" indent="0" algn="l">
-              <a:spcBef>
-                <a:spcPts val="0"/>
-              </a:spcBef>
-              <a:buNone/>
-            </a:pPr>
-            <a:r>
-              <a:rPr lang="en-US" sz="1100" b="0" dirty="0">
-                <a:solidFill>
-                  <a:srgbClr val="5B6773"/>
-                </a:solidFill>
-                <a:latin typeface="Courier New"/>
-                <a:cs typeface="Courier New"/>
-              </a:rPr>
-              <a:t>/cmd_vel</a:t>
-            </a:r>
-          </a:p>
-        </p:txBody>
-      </p:sp>
-      <p:sp>
-        <p:nvSpPr>
-          <p:cNvPr id="26" name="Topic (manual)"/>
-          <p:cNvSpPr txBox="1"/>
-          <p:nvPr/>
-        </p:nvSpPr>
-        <p:spPr>
-          <a:xfrm>
-            <a:off x="10826496" y="4576572"/>
-            <a:ext cx="914400" cy="274320"/>
-          </a:xfrm>
-          <a:prstGeom prst="rect">
-            <a:avLst/>
-          </a:prstGeom>
-          <a:noFill/>
-        </p:spPr>
-        <p:txBody>
-          <a:bodyPr wrap="square" lIns="0" tIns="0" rIns="0" bIns="0" anchor="ctr">
-            <a:noAutofit/>
-          </a:bodyPr>
-          <a:lstStyle/>
-          <a:p>
-            <a:pPr marL="0" indent="0" algn="l">
-              <a:spcBef>
-                <a:spcPts val="0"/>
-              </a:spcBef>
-              <a:buNone/>
-            </a:pPr>
-            <a:r>
-              <a:rPr lang="en-US" sz="1100" b="0" dirty="0">
-                <a:solidFill>
-                  <a:srgbClr val="5B6773"/>
-                </a:solidFill>
-                <a:latin typeface="Courier New"/>
-                <a:cs typeface="Courier New"/>
-              </a:rPr>
-              <a:t>(manual)</a:t>
-            </a:r>
-          </a:p>
-        </p:txBody>
-      </p:sp>
+      </p:pic>
     </p:spTree>
   </p:cSld>
   <p:clrMapOvr>

</xml_diff>